<commit_message>
docs: update author to MOHD UBES and tailor presentation to Qualcomm Snapdragon Challenge
</commit_message>
<xml_diff>
--- a/Kisan_Sahayak_AI_Pitch_Presentation.pptx
+++ b/Kisan_Sahayak_AI_Pitch_Presentation.pptx
@@ -3140,7 +3140,7 @@
           <a:lstStyle/>
           <a:p>
             <a:pPr algn="ctr">
-              <a:defRPr sz="2400" b="1">
+              <a:defRPr sz="2300" b="1">
                 <a:solidFill>
                   <a:srgbClr val="0F172A"/>
                 </a:solidFill>
@@ -3148,7 +3148,7 @@
               </a:defRPr>
             </a:pPr>
             <a:r>
-              <a:t>SMART INDIA HACKATHON 2026</a:t>
+              <a:t>QUALCOMM SNAPDRAGON® AI LAB CHALLENGE 2026</a:t>
             </a:r>
             <a:br/>
             <a:r>
@@ -3278,7 +3278,7 @@
                   <a:srgbClr val="0F172A"/>
                 </a:solidFill>
               </a:rPr>
-              <a:t>• Problem Statement ID: </a:t>
+              <a:t>• Project Title: </a:t>
             </a:r>
             <a:r>
               <a:rPr b="1" sz="1100">
@@ -3286,7 +3286,7 @@
                   <a:srgbClr val="0F172A"/>
                 </a:solidFill>
               </a:rPr>
-              <a:t>SIH26091 / QCOM-AGRI-04</a:t>
+              <a:t>Kisan Sahayak AI (किसान सहायक AI)</a:t>
             </a:r>
           </a:p>
           <a:p>
@@ -3301,7 +3301,7 @@
                   <a:srgbClr val="0F172A"/>
                 </a:solidFill>
               </a:rPr>
-              <a:t>• Problem Statement Title: </a:t>
+              <a:t>• Developer / Innovator: </a:t>
             </a:r>
             <a:r>
               <a:rPr b="1" sz="1100">
@@ -3309,7 +3309,7 @@
                   <a:srgbClr val="2563EB"/>
                 </a:solidFill>
               </a:rPr>
-              <a:t>AI-Driven Hyper-Local Multilingual Agronomic Advisory &amp; Crop Disease Diagnosis for Rural Micro-Entrepreneurs &amp; Farmers</a:t>
+              <a:t>MOHD UBES</a:t>
             </a:r>
           </a:p>
           <a:p>
@@ -3324,15 +3324,15 @@
                   <a:srgbClr val="0F172A"/>
                 </a:solidFill>
               </a:rPr>
-              <a:t>• Theme: </a:t>
-            </a:r>
-            <a:r>
-              <a:rPr b="0" sz="1100">
+              <a:t>• Challenge Track: </a:t>
+            </a:r>
+            <a:r>
+              <a:rPr b="1" sz="1100">
                 <a:solidFill>
                   <a:srgbClr val="059669"/>
                 </a:solidFill>
               </a:rPr>
-              <a:t>Agriculture, FoodTech &amp; Rural Development</a:t>
+              <a:t>Agriculture, FoodTech &amp; Rural AI</a:t>
             </a:r>
           </a:p>
           <a:p>
@@ -3347,7 +3347,7 @@
                   <a:srgbClr val="0F172A"/>
                 </a:solidFill>
               </a:rPr>
-              <a:t>• PS Category: </a:t>
+              <a:t>• Category: </a:t>
             </a:r>
             <a:r>
               <a:rPr b="0" sz="1100">
@@ -3355,7 +3355,7 @@
                   <a:srgbClr val="334155"/>
                 </a:solidFill>
               </a:rPr>
-              <a:t>Software / Edge AI</a:t>
+              <a:t>Software / On-Device Edge AI</a:t>
             </a:r>
           </a:p>
           <a:p>
@@ -3370,15 +3370,15 @@
                   <a:srgbClr val="0F172A"/>
                 </a:solidFill>
               </a:rPr>
-              <a:t>• Team Name (Registered): </a:t>
+              <a:t>• Target Hardware: </a:t>
             </a:r>
             <a:r>
               <a:rPr b="1" sz="1100">
                 <a:solidFill>
-                  <a:srgbClr val="0F172A"/>
+                  <a:srgbClr val="D97706"/>
                 </a:solidFill>
               </a:rPr>
-              <a:t>Pantheon Eternal</a:t>
+              <a:t>Qualcomm Snapdragon® X Elite (Hexagon™ NPU 45 TOPS, Adreno™ GPU)</a:t>
             </a:r>
           </a:p>
           <a:p>
@@ -3393,15 +3393,15 @@
                   <a:srgbClr val="0F172A"/>
                 </a:solidFill>
               </a:rPr>
-              <a:t>• Hardware Accelerator: </a:t>
-            </a:r>
-            <a:r>
-              <a:rPr b="1" sz="1100">
-                <a:solidFill>
-                  <a:srgbClr val="D97706"/>
+              <a:t>• Deployment Status: </a:t>
+            </a:r>
+            <a:r>
+              <a:rPr b="0" sz="1100">
+                <a:solidFill>
+                  <a:srgbClr val="334155"/>
                 </a:solidFill>
               </a:rPr>
-              <a:t>Snapdragon® X Elite (Hexagon™ NPU 45 TOPS, Adreno™ GPU)</a:t>
+              <a:t>Live on Vercel &amp; 100% Offline Progressive Web App (PWA)</a:t>
             </a:r>
           </a:p>
           <a:p>
@@ -3416,15 +3416,15 @@
                   <a:srgbClr val="0F172A"/>
                 </a:solidFill>
               </a:rPr>
-              <a:t>• Deployment Status: </a:t>
+              <a:t>• Live Web Application: </a:t>
             </a:r>
             <a:r>
               <a:rPr b="0" sz="1100">
                 <a:solidFill>
-                  <a:srgbClr val="334155"/>
+                  <a:srgbClr val="2563EB"/>
                 </a:solidFill>
               </a:rPr>
-              <a:t>Live on Vercel &amp; Fully Functional Offline PWA</a:t>
+              <a:t>https://kisan-sahayak-ai-ivory.vercel.app</a:t>
             </a:r>
           </a:p>
           <a:p>
@@ -3439,7 +3439,7 @@
                   <a:srgbClr val="0F172A"/>
                 </a:solidFill>
               </a:rPr>
-              <a:t>• Live Web App: </a:t>
+              <a:t>• GitHub Repository: </a:t>
             </a:r>
             <a:r>
               <a:rPr b="0" sz="1100">
@@ -3447,7 +3447,7 @@
                   <a:srgbClr val="2563EB"/>
                 </a:solidFill>
               </a:rPr>
-              <a:t>https://kisan-sahayak-ai-ivory.vercel.app</a:t>
+              <a:t>https://github.com/MOHDUBES/Kisan-Sahayak-AI</a:t>
             </a:r>
           </a:p>
           <a:p>
@@ -3462,15 +3462,15 @@
                   <a:srgbClr val="0F172A"/>
                 </a:solidFill>
               </a:rPr>
-              <a:t>• GitHub Repository: </a:t>
+              <a:t>• Core Capabilities: </a:t>
             </a:r>
             <a:r>
               <a:rPr b="0" sz="1100">
                 <a:solidFill>
-                  <a:srgbClr val="2563EB"/>
+                  <a:srgbClr val="0F172A"/>
                 </a:solidFill>
               </a:rPr>
-              <a:t>https://github.com/MOHDUBES/Kisan-Sahayak-AI</a:t>
+              <a:t>Sub-20ms Crop Disease Vision, 10+ Indic Languages Speech, 15+ Central/State Subsidies</a:t>
             </a:r>
           </a:p>
         </p:txBody>
@@ -3547,7 +3547,7 @@
               </a:defRPr>
             </a:pPr>
             <a:r>
-              <a:t>@SIH Idea Submission- Template  |  Qualcomm Snapdragon® AI Lab Build &amp; Present Challenge 2026                 Page 1</a:t>
+              <a:t>@Qualcomm Snapdragon® AI Lab Build &amp; Present Challenge 2026  |  Project: Kisan Sahayak AI  |  Developer: MOHD UBES                 Page 1</a:t>
             </a:r>
           </a:p>
         </p:txBody>
@@ -3617,7 +3617,7 @@
           <a:lstStyle/>
           <a:p>
             <a:pPr algn="ctr">
-              <a:defRPr sz="2200" b="1">
+              <a:defRPr sz="2100" b="1">
                 <a:solidFill>
                   <a:srgbClr val="0F172A"/>
                 </a:solidFill>
@@ -4351,7 +4351,7 @@
               </a:defRPr>
             </a:pPr>
             <a:r>
-              <a:t>Problem: Agronomists take days to visit remote farms.</a:t>
+              <a:t>Problem: Agronomists take days to reach rural villages.</a:t>
             </a:r>
             <a:br/>
             <a:r>
@@ -5047,7 +5047,7 @@
               </a:defRPr>
             </a:pPr>
             <a:r>
-              <a:t>@SIH Idea Submission- Template  |  Qualcomm Snapdragon® AI Lab Build &amp; Present Challenge 2026                 Page 2</a:t>
+              <a:t>@Qualcomm Snapdragon® AI Lab Build &amp; Present Challenge 2026  |  Project: Kisan Sahayak AI  |  Developer: MOHD UBES                 Page 2</a:t>
             </a:r>
           </a:p>
         </p:txBody>
@@ -5117,7 +5117,7 @@
           <a:lstStyle/>
           <a:p>
             <a:pPr algn="ctr">
-              <a:defRPr sz="2200" b="1">
+              <a:defRPr sz="2100" b="1">
                 <a:solidFill>
                   <a:srgbClr val="0F172A"/>
                 </a:solidFill>
@@ -5562,7 +5562,7 @@
               </a:defRPr>
             </a:pPr>
             <a:r>
-              <a:t>@SIH Idea Submission- Template  |  Qualcomm Snapdragon® AI Lab Build &amp; Present Challenge 2026                 Page 3</a:t>
+              <a:t>@Qualcomm Snapdragon® AI Lab Build &amp; Present Challenge 2026  |  Project: Kisan Sahayak AI  |  Developer: MOHD UBES                 Page 3</a:t>
             </a:r>
           </a:p>
         </p:txBody>
@@ -5632,7 +5632,7 @@
           <a:lstStyle/>
           <a:p>
             <a:pPr algn="ctr">
-              <a:defRPr sz="2200" b="1">
+              <a:defRPr sz="2100" b="1">
                 <a:solidFill>
                   <a:srgbClr val="0F172A"/>
                 </a:solidFill>
@@ -5790,7 +5790,7 @@
               </a:defRPr>
             </a:pPr>
             <a:r>
-              <a:t>@SIH Idea Submission- Template  |  Qualcomm Snapdragon® AI Lab Build &amp; Present Challenge 2026                 Page 4</a:t>
+              <a:t>@Qualcomm Snapdragon® AI Lab Build &amp; Present Challenge 2026  |  Project: Kisan Sahayak AI  |  Developer: MOHD UBES                 Page 4</a:t>
             </a:r>
           </a:p>
         </p:txBody>
@@ -5860,7 +5860,7 @@
           <a:lstStyle/>
           <a:p>
             <a:pPr algn="ctr">
-              <a:defRPr sz="2200" b="1">
+              <a:defRPr sz="2100" b="1">
                 <a:solidFill>
                   <a:srgbClr val="0F172A"/>
                 </a:solidFill>
@@ -6773,7 +6773,7 @@
               </a:defRPr>
             </a:pPr>
             <a:r>
-              <a:t>@SIH Idea Submission- Template  |  Qualcomm Snapdragon® AI Lab Build &amp; Present Challenge 2026                 Page 5</a:t>
+              <a:t>@Qualcomm Snapdragon® AI Lab Build &amp; Present Challenge 2026  |  Project: Kisan Sahayak AI  |  Developer: MOHD UBES                 Page 5</a:t>
             </a:r>
           </a:p>
         </p:txBody>
@@ -6843,7 +6843,7 @@
           <a:lstStyle/>
           <a:p>
             <a:pPr algn="ctr">
-              <a:defRPr sz="2200" b="1">
+              <a:defRPr sz="2100" b="1">
                 <a:solidFill>
                   <a:srgbClr val="0F172A"/>
                 </a:solidFill>
@@ -7904,7 +7904,7 @@
               </a:defRPr>
             </a:pPr>
             <a:r>
-              <a:t>@SIH Idea Submission- Template  |  Qualcomm Snapdragon® AI Lab Build &amp; Present Challenge 2026                 Page 6</a:t>
+              <a:t>@Qualcomm Snapdragon® AI Lab Build &amp; Present Challenge 2026  |  Project: Kisan Sahayak AI  |  Developer: MOHD UBES                 Page 6</a:t>
             </a:r>
           </a:p>
         </p:txBody>

</xml_diff>

<commit_message>
style: remove hackathon bulb logo from presentation header
</commit_message>
<xml_diff>
--- a/Kisan_Sahayak_AI_Pitch_Presentation.pptx
+++ b/Kisan_Sahayak_AI_Pitch_Presentation.pptx
@@ -3125,8 +3125,8 @@
         </p:nvSpPr>
         <p:spPr>
           <a:xfrm>
-            <a:off x="1645920" y="274320"/>
-            <a:ext cx="8046720" cy="868680"/>
+            <a:off x="1463040" y="274320"/>
+            <a:ext cx="10241280" cy="868680"/>
           </a:xfrm>
           <a:prstGeom prst="rect">
             <a:avLst/>
@@ -3140,7 +3140,7 @@
           <a:lstStyle/>
           <a:p>
             <a:pPr algn="ctr">
-              <a:defRPr sz="2300" b="1">
+              <a:defRPr sz="2400" b="1">
                 <a:solidFill>
                   <a:srgbClr val="0F172A"/>
                 </a:solidFill>
@@ -3148,18 +3148,312 @@
               </a:defRPr>
             </a:pPr>
             <a:r>
-              <a:t>QUALCOMM SNAPDRAGON® AI LAB CHALLENGE 2026</a:t>
+              <a:t>KISAN SAHAYAK AI (किसान सहायक AI)</a:t>
             </a:r>
             <a:br/>
             <a:r>
-              <a:t>TITLE PAGE</a:t>
+              <a:t>On-Device Multilingual Agronomic Advisory &amp; Pest Diagnosis System</a:t>
+            </a:r>
+          </a:p>
+        </p:txBody>
+      </p:sp>
+      <p:sp>
+        <p:nvSpPr>
+          <p:cNvPr id="4" name="Rectangle 3"/>
+          <p:cNvSpPr/>
+          <p:nvPr/>
+        </p:nvSpPr>
+        <p:spPr>
+          <a:xfrm>
+            <a:off x="457200" y="1234440"/>
+            <a:ext cx="11277295" cy="18288"/>
+          </a:xfrm>
+          <a:prstGeom prst="rect">
+            <a:avLst/>
+          </a:prstGeom>
+          <a:solidFill>
+            <a:srgbClr val="E2E8F0"/>
+          </a:solidFill>
+          <a:ln>
+            <a:solidFill>
+              <a:srgbClr val="E2E8F0"/>
+            </a:solidFill>
+          </a:ln>
+        </p:spPr>
+        <p:style>
+          <a:lnRef idx="1">
+            <a:schemeClr val="accent1"/>
+          </a:lnRef>
+          <a:fillRef idx="3">
+            <a:schemeClr val="accent1"/>
+          </a:fillRef>
+          <a:effectRef idx="2">
+            <a:schemeClr val="accent1"/>
+          </a:effectRef>
+          <a:fontRef idx="minor">
+            <a:schemeClr val="lt1"/>
+          </a:fontRef>
+        </p:style>
+        <p:txBody>
+          <a:bodyPr rtlCol="0" anchor="ctr"/>
+          <a:lstStyle/>
+          <a:p>
+            <a:pPr algn="ctr"/>
+          </a:p>
+        </p:txBody>
+      </p:sp>
+      <p:sp>
+        <p:nvSpPr>
+          <p:cNvPr id="5" name="Rounded Rectangle 4"/>
+          <p:cNvSpPr/>
+          <p:nvPr/>
+        </p:nvSpPr>
+        <p:spPr>
+          <a:xfrm>
+            <a:off x="548640" y="1371600"/>
+            <a:ext cx="6217920" cy="4937760"/>
+          </a:xfrm>
+          <a:prstGeom prst="roundRect">
+            <a:avLst/>
+          </a:prstGeom>
+          <a:solidFill>
+            <a:srgbClr val="FFFFFF"/>
+          </a:solidFill>
+          <a:ln w="19050">
+            <a:solidFill>
+              <a:srgbClr val="E2E8F0"/>
+            </a:solidFill>
+          </a:ln>
+        </p:spPr>
+        <p:style>
+          <a:lnRef idx="1">
+            <a:schemeClr val="accent1"/>
+          </a:lnRef>
+          <a:fillRef idx="3">
+            <a:schemeClr val="accent1"/>
+          </a:fillRef>
+          <a:effectRef idx="2">
+            <a:schemeClr val="accent1"/>
+          </a:effectRef>
+          <a:fontRef idx="minor">
+            <a:schemeClr val="lt1"/>
+          </a:fontRef>
+        </p:style>
+        <p:txBody>
+          <a:bodyPr rtlCol="0" anchor="ctr" wrap="square" lIns="274320" rIns="274320" tIns="228600"/>
+          <a:lstStyle/>
+          <a:p>
+            <a:pPr algn="ctr">
+              <a:spcAft>
+                <a:spcPts val="700"/>
+              </a:spcAft>
+            </a:pPr>
+            <a:r>
+              <a:rPr b="1" sz="1100">
+                <a:solidFill>
+                  <a:srgbClr val="0F172A"/>
+                </a:solidFill>
+              </a:rPr>
+              <a:t>• Project Name: </a:t>
+            </a:r>
+            <a:r>
+              <a:rPr b="1" sz="1100">
+                <a:solidFill>
+                  <a:srgbClr val="0F172A"/>
+                </a:solidFill>
+              </a:rPr>
+              <a:t>Kisan Sahayak AI (किसान सहायक AI)</a:t>
+            </a:r>
+          </a:p>
+          <a:p>
+            <a:pPr>
+              <a:spcAft>
+                <a:spcPts val="700"/>
+              </a:spcAft>
+            </a:pPr>
+            <a:r>
+              <a:rPr b="1" sz="1100">
+                <a:solidFill>
+                  <a:srgbClr val="0F172A"/>
+                </a:solidFill>
+              </a:rPr>
+              <a:t>• Developer / Author: </a:t>
+            </a:r>
+            <a:r>
+              <a:rPr b="1" sz="1100">
+                <a:solidFill>
+                  <a:srgbClr val="2563EB"/>
+                </a:solidFill>
+              </a:rPr>
+              <a:t>MOHD UBES</a:t>
+            </a:r>
+          </a:p>
+          <a:p>
+            <a:pPr>
+              <a:spcAft>
+                <a:spcPts val="700"/>
+              </a:spcAft>
+            </a:pPr>
+            <a:r>
+              <a:rPr b="1" sz="1100">
+                <a:solidFill>
+                  <a:srgbClr val="0F172A"/>
+                </a:solidFill>
+              </a:rPr>
+              <a:t>• Domain &amp; Category: </a:t>
+            </a:r>
+            <a:r>
+              <a:rPr b="1" sz="1100">
+                <a:solidFill>
+                  <a:srgbClr val="059669"/>
+                </a:solidFill>
+              </a:rPr>
+              <a:t>Agriculture, FoodTech &amp; Rural AI</a:t>
+            </a:r>
+          </a:p>
+          <a:p>
+            <a:pPr>
+              <a:spcAft>
+                <a:spcPts val="700"/>
+              </a:spcAft>
+            </a:pPr>
+            <a:r>
+              <a:rPr b="1" sz="1100">
+                <a:solidFill>
+                  <a:srgbClr val="0F172A"/>
+                </a:solidFill>
+              </a:rPr>
+              <a:t>• Execution Mode: </a:t>
+            </a:r>
+            <a:r>
+              <a:rPr b="0" sz="1100">
+                <a:solidFill>
+                  <a:srgbClr val="334155"/>
+                </a:solidFill>
+              </a:rPr>
+              <a:t>100% On-Device Edge AI / Zero Cloud Latency</a:t>
+            </a:r>
+          </a:p>
+          <a:p>
+            <a:pPr>
+              <a:spcAft>
+                <a:spcPts val="700"/>
+              </a:spcAft>
+            </a:pPr>
+            <a:r>
+              <a:rPr b="1" sz="1100">
+                <a:solidFill>
+                  <a:srgbClr val="0F172A"/>
+                </a:solidFill>
+              </a:rPr>
+              <a:t>• Hardware Accelerator: </a:t>
+            </a:r>
+            <a:r>
+              <a:rPr b="1" sz="1100">
+                <a:solidFill>
+                  <a:srgbClr val="D97706"/>
+                </a:solidFill>
+              </a:rPr>
+              <a:t>Qualcomm Snapdragon® X Elite (Hexagon™ NPU 45 TOPS)</a:t>
+            </a:r>
+          </a:p>
+          <a:p>
+            <a:pPr>
+              <a:spcAft>
+                <a:spcPts val="700"/>
+              </a:spcAft>
+            </a:pPr>
+            <a:r>
+              <a:rPr b="1" sz="1100">
+                <a:solidFill>
+                  <a:srgbClr val="0F172A"/>
+                </a:solidFill>
+              </a:rPr>
+              <a:t>• Deployment Status: </a:t>
+            </a:r>
+            <a:r>
+              <a:rPr b="0" sz="1100">
+                <a:solidFill>
+                  <a:srgbClr val="334155"/>
+                </a:solidFill>
+              </a:rPr>
+              <a:t>Live on Vercel &amp; Fully Functional Offline PWA</a:t>
+            </a:r>
+          </a:p>
+          <a:p>
+            <a:pPr>
+              <a:spcAft>
+                <a:spcPts val="700"/>
+              </a:spcAft>
+            </a:pPr>
+            <a:r>
+              <a:rPr b="1" sz="1100">
+                <a:solidFill>
+                  <a:srgbClr val="0F172A"/>
+                </a:solidFill>
+              </a:rPr>
+              <a:t>• Live Web Application: </a:t>
+            </a:r>
+            <a:r>
+              <a:rPr b="0" sz="1100">
+                <a:solidFill>
+                  <a:srgbClr val="2563EB"/>
+                </a:solidFill>
+              </a:rPr>
+              <a:t>https://kisan-sahayak-ai-ivory.vercel.app</a:t>
+            </a:r>
+          </a:p>
+          <a:p>
+            <a:pPr>
+              <a:spcAft>
+                <a:spcPts val="700"/>
+              </a:spcAft>
+            </a:pPr>
+            <a:r>
+              <a:rPr b="1" sz="1100">
+                <a:solidFill>
+                  <a:srgbClr val="0F172A"/>
+                </a:solidFill>
+              </a:rPr>
+              <a:t>• GitHub Repository: </a:t>
+            </a:r>
+            <a:r>
+              <a:rPr b="0" sz="1100">
+                <a:solidFill>
+                  <a:srgbClr val="2563EB"/>
+                </a:solidFill>
+              </a:rPr>
+              <a:t>https://github.com/MOHDUBES/Kisan-Sahayak-AI</a:t>
+            </a:r>
+          </a:p>
+          <a:p>
+            <a:pPr>
+              <a:spcAft>
+                <a:spcPts val="700"/>
+              </a:spcAft>
+            </a:pPr>
+            <a:r>
+              <a:rPr b="1" sz="1100">
+                <a:solidFill>
+                  <a:srgbClr val="0F172A"/>
+                </a:solidFill>
+              </a:rPr>
+              <a:t>• Core Capabilities: </a:t>
+            </a:r>
+            <a:r>
+              <a:rPr b="0" sz="1100">
+                <a:solidFill>
+                  <a:srgbClr val="0F172A"/>
+                </a:solidFill>
+              </a:rPr>
+              <a:t>Sub-20ms Crop Disease Vision, 10+ Indic Languages Speech, 15+ Central/State Subsidies</a:t>
             </a:r>
           </a:p>
         </p:txBody>
       </p:sp>
       <p:pic>
         <p:nvPicPr>
-          <p:cNvPr id="4" name="Picture 3" descr="challenge_logo.png"/>
+          <p:cNvPr id="6" name="Picture 5" descr="slide1_hero.png"/>
           <p:cNvPicPr>
             <a:picLocks noChangeAspect="1"/>
           </p:cNvPicPr>
@@ -3173,8 +3467,8 @@
         </p:blipFill>
         <p:spPr>
           <a:xfrm>
-            <a:off x="10058400" y="228600"/>
-            <a:ext cx="1645920" cy="914400"/>
+            <a:off x="7040880" y="1371600"/>
+            <a:ext cx="4572000" cy="4937760"/>
           </a:xfrm>
           <a:prstGeom prst="rect">
             <a:avLst/>
@@ -3183,325 +3477,7 @@
       </p:pic>
       <p:sp>
         <p:nvSpPr>
-          <p:cNvPr id="5" name="Rectangle 4"/>
-          <p:cNvSpPr/>
-          <p:nvPr/>
-        </p:nvSpPr>
-        <p:spPr>
-          <a:xfrm>
-            <a:off x="457200" y="1234440"/>
-            <a:ext cx="11277295" cy="18288"/>
-          </a:xfrm>
-          <a:prstGeom prst="rect">
-            <a:avLst/>
-          </a:prstGeom>
-          <a:solidFill>
-            <a:srgbClr val="E2E8F0"/>
-          </a:solidFill>
-          <a:ln>
-            <a:solidFill>
-              <a:srgbClr val="E2E8F0"/>
-            </a:solidFill>
-          </a:ln>
-        </p:spPr>
-        <p:style>
-          <a:lnRef idx="1">
-            <a:schemeClr val="accent1"/>
-          </a:lnRef>
-          <a:fillRef idx="3">
-            <a:schemeClr val="accent1"/>
-          </a:fillRef>
-          <a:effectRef idx="2">
-            <a:schemeClr val="accent1"/>
-          </a:effectRef>
-          <a:fontRef idx="minor">
-            <a:schemeClr val="lt1"/>
-          </a:fontRef>
-        </p:style>
-        <p:txBody>
-          <a:bodyPr rtlCol="0" anchor="ctr"/>
-          <a:lstStyle/>
-          <a:p>
-            <a:pPr algn="ctr"/>
-          </a:p>
-        </p:txBody>
-      </p:sp>
-      <p:sp>
-        <p:nvSpPr>
-          <p:cNvPr id="6" name="Rounded Rectangle 5"/>
-          <p:cNvSpPr/>
-          <p:nvPr/>
-        </p:nvSpPr>
-        <p:spPr>
-          <a:xfrm>
-            <a:off x="548640" y="1371600"/>
-            <a:ext cx="6217920" cy="4937760"/>
-          </a:xfrm>
-          <a:prstGeom prst="roundRect">
-            <a:avLst/>
-          </a:prstGeom>
-          <a:solidFill>
-            <a:srgbClr val="FFFFFF"/>
-          </a:solidFill>
-          <a:ln w="19050">
-            <a:solidFill>
-              <a:srgbClr val="E2E8F0"/>
-            </a:solidFill>
-          </a:ln>
-        </p:spPr>
-        <p:style>
-          <a:lnRef idx="1">
-            <a:schemeClr val="accent1"/>
-          </a:lnRef>
-          <a:fillRef idx="3">
-            <a:schemeClr val="accent1"/>
-          </a:fillRef>
-          <a:effectRef idx="2">
-            <a:schemeClr val="accent1"/>
-          </a:effectRef>
-          <a:fontRef idx="minor">
-            <a:schemeClr val="lt1"/>
-          </a:fontRef>
-        </p:style>
-        <p:txBody>
-          <a:bodyPr rtlCol="0" anchor="ctr" wrap="square" lIns="274320" rIns="274320" tIns="228600"/>
-          <a:lstStyle/>
-          <a:p>
-            <a:pPr algn="ctr">
-              <a:spcAft>
-                <a:spcPts val="700"/>
-              </a:spcAft>
-            </a:pPr>
-            <a:r>
-              <a:rPr b="1" sz="1100">
-                <a:solidFill>
-                  <a:srgbClr val="0F172A"/>
-                </a:solidFill>
-              </a:rPr>
-              <a:t>• Project Title: </a:t>
-            </a:r>
-            <a:r>
-              <a:rPr b="1" sz="1100">
-                <a:solidFill>
-                  <a:srgbClr val="0F172A"/>
-                </a:solidFill>
-              </a:rPr>
-              <a:t>Kisan Sahayak AI (किसान सहायक AI)</a:t>
-            </a:r>
-          </a:p>
-          <a:p>
-            <a:pPr>
-              <a:spcAft>
-                <a:spcPts val="700"/>
-              </a:spcAft>
-            </a:pPr>
-            <a:r>
-              <a:rPr b="1" sz="1100">
-                <a:solidFill>
-                  <a:srgbClr val="0F172A"/>
-                </a:solidFill>
-              </a:rPr>
-              <a:t>• Developer / Innovator: </a:t>
-            </a:r>
-            <a:r>
-              <a:rPr b="1" sz="1100">
-                <a:solidFill>
-                  <a:srgbClr val="2563EB"/>
-                </a:solidFill>
-              </a:rPr>
-              <a:t>MOHD UBES</a:t>
-            </a:r>
-          </a:p>
-          <a:p>
-            <a:pPr>
-              <a:spcAft>
-                <a:spcPts val="700"/>
-              </a:spcAft>
-            </a:pPr>
-            <a:r>
-              <a:rPr b="1" sz="1100">
-                <a:solidFill>
-                  <a:srgbClr val="0F172A"/>
-                </a:solidFill>
-              </a:rPr>
-              <a:t>• Challenge Track: </a:t>
-            </a:r>
-            <a:r>
-              <a:rPr b="1" sz="1100">
-                <a:solidFill>
-                  <a:srgbClr val="059669"/>
-                </a:solidFill>
-              </a:rPr>
-              <a:t>Agriculture, FoodTech &amp; Rural AI</a:t>
-            </a:r>
-          </a:p>
-          <a:p>
-            <a:pPr>
-              <a:spcAft>
-                <a:spcPts val="700"/>
-              </a:spcAft>
-            </a:pPr>
-            <a:r>
-              <a:rPr b="1" sz="1100">
-                <a:solidFill>
-                  <a:srgbClr val="0F172A"/>
-                </a:solidFill>
-              </a:rPr>
-              <a:t>• Category: </a:t>
-            </a:r>
-            <a:r>
-              <a:rPr b="0" sz="1100">
-                <a:solidFill>
-                  <a:srgbClr val="334155"/>
-                </a:solidFill>
-              </a:rPr>
-              <a:t>Software / On-Device Edge AI</a:t>
-            </a:r>
-          </a:p>
-          <a:p>
-            <a:pPr>
-              <a:spcAft>
-                <a:spcPts val="700"/>
-              </a:spcAft>
-            </a:pPr>
-            <a:r>
-              <a:rPr b="1" sz="1100">
-                <a:solidFill>
-                  <a:srgbClr val="0F172A"/>
-                </a:solidFill>
-              </a:rPr>
-              <a:t>• Target Hardware: </a:t>
-            </a:r>
-            <a:r>
-              <a:rPr b="1" sz="1100">
-                <a:solidFill>
-                  <a:srgbClr val="D97706"/>
-                </a:solidFill>
-              </a:rPr>
-              <a:t>Qualcomm Snapdragon® X Elite (Hexagon™ NPU 45 TOPS, Adreno™ GPU)</a:t>
-            </a:r>
-          </a:p>
-          <a:p>
-            <a:pPr>
-              <a:spcAft>
-                <a:spcPts val="700"/>
-              </a:spcAft>
-            </a:pPr>
-            <a:r>
-              <a:rPr b="1" sz="1100">
-                <a:solidFill>
-                  <a:srgbClr val="0F172A"/>
-                </a:solidFill>
-              </a:rPr>
-              <a:t>• Deployment Status: </a:t>
-            </a:r>
-            <a:r>
-              <a:rPr b="0" sz="1100">
-                <a:solidFill>
-                  <a:srgbClr val="334155"/>
-                </a:solidFill>
-              </a:rPr>
-              <a:t>Live on Vercel &amp; 100% Offline Progressive Web App (PWA)</a:t>
-            </a:r>
-          </a:p>
-          <a:p>
-            <a:pPr>
-              <a:spcAft>
-                <a:spcPts val="700"/>
-              </a:spcAft>
-            </a:pPr>
-            <a:r>
-              <a:rPr b="1" sz="1100">
-                <a:solidFill>
-                  <a:srgbClr val="0F172A"/>
-                </a:solidFill>
-              </a:rPr>
-              <a:t>• Live Web Application: </a:t>
-            </a:r>
-            <a:r>
-              <a:rPr b="0" sz="1100">
-                <a:solidFill>
-                  <a:srgbClr val="2563EB"/>
-                </a:solidFill>
-              </a:rPr>
-              <a:t>https://kisan-sahayak-ai-ivory.vercel.app</a:t>
-            </a:r>
-          </a:p>
-          <a:p>
-            <a:pPr>
-              <a:spcAft>
-                <a:spcPts val="700"/>
-              </a:spcAft>
-            </a:pPr>
-            <a:r>
-              <a:rPr b="1" sz="1100">
-                <a:solidFill>
-                  <a:srgbClr val="0F172A"/>
-                </a:solidFill>
-              </a:rPr>
-              <a:t>• GitHub Repository: </a:t>
-            </a:r>
-            <a:r>
-              <a:rPr b="0" sz="1100">
-                <a:solidFill>
-                  <a:srgbClr val="2563EB"/>
-                </a:solidFill>
-              </a:rPr>
-              <a:t>https://github.com/MOHDUBES/Kisan-Sahayak-AI</a:t>
-            </a:r>
-          </a:p>
-          <a:p>
-            <a:pPr>
-              <a:spcAft>
-                <a:spcPts val="700"/>
-              </a:spcAft>
-            </a:pPr>
-            <a:r>
-              <a:rPr b="1" sz="1100">
-                <a:solidFill>
-                  <a:srgbClr val="0F172A"/>
-                </a:solidFill>
-              </a:rPr>
-              <a:t>• Core Capabilities: </a:t>
-            </a:r>
-            <a:r>
-              <a:rPr b="0" sz="1100">
-                <a:solidFill>
-                  <a:srgbClr val="0F172A"/>
-                </a:solidFill>
-              </a:rPr>
-              <a:t>Sub-20ms Crop Disease Vision, 10+ Indic Languages Speech, 15+ Central/State Subsidies</a:t>
-            </a:r>
-          </a:p>
-        </p:txBody>
-      </p:sp>
-      <p:pic>
-        <p:nvPicPr>
-          <p:cNvPr id="7" name="Picture 6" descr="slide1_hero.png"/>
-          <p:cNvPicPr>
-            <a:picLocks noChangeAspect="1"/>
-          </p:cNvPicPr>
-          <p:nvPr/>
-        </p:nvPicPr>
-        <p:blipFill>
-          <a:blip r:embed="rId4"/>
-          <a:stretch>
-            <a:fillRect/>
-          </a:stretch>
-        </p:blipFill>
-        <p:spPr>
-          <a:xfrm>
-            <a:off x="7040880" y="1371600"/>
-            <a:ext cx="4572000" cy="4937760"/>
-          </a:xfrm>
-          <a:prstGeom prst="rect">
-            <a:avLst/>
-          </a:prstGeom>
-        </p:spPr>
-      </p:pic>
-      <p:sp>
-        <p:nvSpPr>
-          <p:cNvPr id="8" name="Rectangle 7"/>
+          <p:cNvPr id="7" name="Rectangle 6"/>
           <p:cNvSpPr/>
           <p:nvPr/>
         </p:nvSpPr>
@@ -3547,7 +3523,7 @@
               </a:defRPr>
             </a:pPr>
             <a:r>
-              <a:t>@Qualcomm Snapdragon® AI Lab Build &amp; Present Challenge 2026  |  Project: Kisan Sahayak AI  |  Developer: MOHD UBES                 Page 1</a:t>
+              <a:t>Project: Kisan Sahayak AI   |   Developer: MOHD UBES   |   Snapdragon® AI Lab Build &amp; Present Challenge 2026                 Page 1</a:t>
             </a:r>
           </a:p>
         </p:txBody>
@@ -3602,8 +3578,8 @@
         </p:nvSpPr>
         <p:spPr>
           <a:xfrm>
-            <a:off x="1645920" y="274320"/>
-            <a:ext cx="8046720" cy="868680"/>
+            <a:off x="1463040" y="274320"/>
+            <a:ext cx="10241280" cy="868680"/>
           </a:xfrm>
           <a:prstGeom prst="rect">
             <a:avLst/>
@@ -3617,7 +3593,7 @@
           <a:lstStyle/>
           <a:p>
             <a:pPr algn="ctr">
-              <a:defRPr sz="2100" b="1">
+              <a:defRPr sz="2200" b="1">
                 <a:solidFill>
                   <a:srgbClr val="0F172A"/>
                 </a:solidFill>
@@ -3625,42 +3601,18 @@
               </a:defRPr>
             </a:pPr>
             <a:r>
-              <a:t>KISAN SAHAYAK AI</a:t>
+              <a:t>PLATFORM OVERVIEW &amp; VALUE PROPOSITION</a:t>
             </a:r>
             <a:br/>
             <a:r>
-              <a:t>Platform Overview, Key Gaps Closed &amp; Unique Innovations</a:t>
-            </a:r>
-          </a:p>
-        </p:txBody>
-      </p:sp>
-      <p:pic>
-        <p:nvPicPr>
-          <p:cNvPr id="4" name="Picture 3" descr="challenge_logo.png"/>
-          <p:cNvPicPr>
-            <a:picLocks noChangeAspect="1"/>
-          </p:cNvPicPr>
-          <p:nvPr/>
-        </p:nvPicPr>
-        <p:blipFill>
-          <a:blip r:embed="rId3"/>
-          <a:stretch>
-            <a:fillRect/>
-          </a:stretch>
-        </p:blipFill>
-        <p:spPr>
-          <a:xfrm>
-            <a:off x="10058400" y="228600"/>
-            <a:ext cx="1645920" cy="914400"/>
-          </a:xfrm>
-          <a:prstGeom prst="rect">
-            <a:avLst/>
-          </a:prstGeom>
-        </p:spPr>
-      </p:pic>
-      <p:sp>
-        <p:nvSpPr>
-          <p:cNvPr id="5" name="Rectangle 4"/>
+              <a:t>End-to-End Workflow, Key Agronomic Gaps Closed &amp; Ground-Level Innovations</a:t>
+            </a:r>
+          </a:p>
+        </p:txBody>
+      </p:sp>
+      <p:sp>
+        <p:nvSpPr>
+          <p:cNvPr id="4" name="Rectangle 3"/>
           <p:cNvSpPr/>
           <p:nvPr/>
         </p:nvSpPr>
@@ -3705,7 +3657,7 @@
       </p:sp>
       <p:sp>
         <p:nvSpPr>
-          <p:cNvPr id="6" name="Rounded Rectangle 5"/>
+          <p:cNvPr id="5" name="Rounded Rectangle 4"/>
           <p:cNvSpPr/>
           <p:nvPr/>
         </p:nvSpPr>
@@ -3750,7 +3702,7 @@
       </p:sp>
       <p:sp>
         <p:nvSpPr>
-          <p:cNvPr id="7" name="Rounded Rectangle 6"/>
+          <p:cNvPr id="6" name="Rounded Rectangle 5"/>
           <p:cNvSpPr/>
           <p:nvPr/>
         </p:nvSpPr>
@@ -3804,7 +3756,7 @@
       </p:sp>
       <p:sp>
         <p:nvSpPr>
-          <p:cNvPr id="8" name="Rounded Rectangle 7"/>
+          <p:cNvPr id="7" name="Rounded Rectangle 6"/>
           <p:cNvSpPr/>
           <p:nvPr/>
         </p:nvSpPr>
@@ -3856,7 +3808,7 @@
       </p:sp>
       <p:sp>
         <p:nvSpPr>
-          <p:cNvPr id="9" name="Rounded Rectangle 8"/>
+          <p:cNvPr id="8" name="Rounded Rectangle 7"/>
           <p:cNvSpPr/>
           <p:nvPr/>
         </p:nvSpPr>
@@ -3908,7 +3860,7 @@
       </p:sp>
       <p:sp>
         <p:nvSpPr>
-          <p:cNvPr id="10" name="Rounded Rectangle 9"/>
+          <p:cNvPr id="9" name="Rounded Rectangle 8"/>
           <p:cNvSpPr/>
           <p:nvPr/>
         </p:nvSpPr>
@@ -3960,7 +3912,7 @@
       </p:sp>
       <p:sp>
         <p:nvSpPr>
-          <p:cNvPr id="11" name="Rounded Rectangle 10"/>
+          <p:cNvPr id="10" name="Rounded Rectangle 9"/>
           <p:cNvSpPr/>
           <p:nvPr/>
         </p:nvSpPr>
@@ -4026,7 +3978,7 @@
       </p:sp>
       <p:sp>
         <p:nvSpPr>
-          <p:cNvPr id="12" name="Rounded Rectangle 11"/>
+          <p:cNvPr id="11" name="Rounded Rectangle 10"/>
           <p:cNvSpPr/>
           <p:nvPr/>
         </p:nvSpPr>
@@ -4092,7 +4044,7 @@
       </p:sp>
       <p:sp>
         <p:nvSpPr>
-          <p:cNvPr id="13" name="Rounded Rectangle 12"/>
+          <p:cNvPr id="12" name="Rounded Rectangle 11"/>
           <p:cNvSpPr/>
           <p:nvPr/>
         </p:nvSpPr>
@@ -4158,7 +4110,7 @@
       </p:sp>
       <p:sp>
         <p:nvSpPr>
-          <p:cNvPr id="14" name="TextBox 13"/>
+          <p:cNvPr id="13" name="TextBox 12"/>
           <p:cNvSpPr txBox="1"/>
           <p:nvPr/>
         </p:nvSpPr>
@@ -4193,7 +4145,7 @@
       </p:sp>
       <p:sp>
         <p:nvSpPr>
-          <p:cNvPr id="15" name="Rounded Rectangle 14"/>
+          <p:cNvPr id="14" name="Rounded Rectangle 13"/>
           <p:cNvSpPr/>
           <p:nvPr/>
         </p:nvSpPr>
@@ -4238,7 +4190,7 @@
       </p:sp>
       <p:sp>
         <p:nvSpPr>
-          <p:cNvPr id="16" name="Rounded Rectangle 15"/>
+          <p:cNvPr id="15" name="Rounded Rectangle 14"/>
           <p:cNvSpPr/>
           <p:nvPr/>
         </p:nvSpPr>
@@ -4292,7 +4244,7 @@
       </p:sp>
       <p:sp>
         <p:nvSpPr>
-          <p:cNvPr id="17" name="Rounded Rectangle 16"/>
+          <p:cNvPr id="16" name="Rounded Rectangle 15"/>
           <p:cNvSpPr/>
           <p:nvPr/>
         </p:nvSpPr>
@@ -4362,7 +4314,7 @@
       </p:sp>
       <p:sp>
         <p:nvSpPr>
-          <p:cNvPr id="18" name="Rounded Rectangle 17"/>
+          <p:cNvPr id="17" name="Rounded Rectangle 16"/>
           <p:cNvSpPr/>
           <p:nvPr/>
         </p:nvSpPr>
@@ -4432,7 +4384,7 @@
       </p:sp>
       <p:sp>
         <p:nvSpPr>
-          <p:cNvPr id="19" name="Rounded Rectangle 18"/>
+          <p:cNvPr id="18" name="Rounded Rectangle 17"/>
           <p:cNvSpPr/>
           <p:nvPr/>
         </p:nvSpPr>
@@ -4502,7 +4454,7 @@
       </p:sp>
       <p:sp>
         <p:nvSpPr>
-          <p:cNvPr id="20" name="TextBox 19"/>
+          <p:cNvPr id="19" name="TextBox 18"/>
           <p:cNvSpPr txBox="1"/>
           <p:nvPr/>
         </p:nvSpPr>
@@ -4537,7 +4489,7 @@
       </p:sp>
       <p:sp>
         <p:nvSpPr>
-          <p:cNvPr id="21" name="Rounded Rectangle 20"/>
+          <p:cNvPr id="20" name="Rounded Rectangle 19"/>
           <p:cNvSpPr/>
           <p:nvPr/>
         </p:nvSpPr>
@@ -4582,7 +4534,7 @@
       </p:sp>
       <p:sp>
         <p:nvSpPr>
-          <p:cNvPr id="22" name="Rounded Rectangle 21"/>
+          <p:cNvPr id="21" name="Rounded Rectangle 20"/>
           <p:cNvSpPr/>
           <p:nvPr/>
         </p:nvSpPr>
@@ -4636,7 +4588,7 @@
       </p:sp>
       <p:sp>
         <p:nvSpPr>
-          <p:cNvPr id="23" name="Rounded Rectangle 22"/>
+          <p:cNvPr id="22" name="Rounded Rectangle 21"/>
           <p:cNvSpPr/>
           <p:nvPr/>
         </p:nvSpPr>
@@ -4702,7 +4654,7 @@
       </p:sp>
       <p:sp>
         <p:nvSpPr>
-          <p:cNvPr id="24" name="Rounded Rectangle 23"/>
+          <p:cNvPr id="23" name="Rounded Rectangle 22"/>
           <p:cNvSpPr/>
           <p:nvPr/>
         </p:nvSpPr>
@@ -4768,7 +4720,7 @@
       </p:sp>
       <p:sp>
         <p:nvSpPr>
-          <p:cNvPr id="25" name="Rounded Rectangle 24"/>
+          <p:cNvPr id="24" name="Rounded Rectangle 23"/>
           <p:cNvSpPr/>
           <p:nvPr/>
         </p:nvSpPr>
@@ -4834,7 +4786,7 @@
       </p:sp>
       <p:sp>
         <p:nvSpPr>
-          <p:cNvPr id="26" name="Rounded Rectangle 25"/>
+          <p:cNvPr id="25" name="Rounded Rectangle 24"/>
           <p:cNvSpPr/>
           <p:nvPr/>
         </p:nvSpPr>
@@ -4900,7 +4852,7 @@
       </p:sp>
       <p:sp>
         <p:nvSpPr>
-          <p:cNvPr id="27" name="Rounded Rectangle 26"/>
+          <p:cNvPr id="26" name="Rounded Rectangle 25"/>
           <p:cNvSpPr/>
           <p:nvPr/>
         </p:nvSpPr>
@@ -4966,7 +4918,7 @@
       </p:sp>
       <p:sp>
         <p:nvSpPr>
-          <p:cNvPr id="28" name="TextBox 27"/>
+          <p:cNvPr id="27" name="TextBox 26"/>
           <p:cNvSpPr txBox="1"/>
           <p:nvPr/>
         </p:nvSpPr>
@@ -5001,7 +4953,7 @@
       </p:sp>
       <p:sp>
         <p:nvSpPr>
-          <p:cNvPr id="29" name="Rectangle 28"/>
+          <p:cNvPr id="28" name="Rectangle 27"/>
           <p:cNvSpPr/>
           <p:nvPr/>
         </p:nvSpPr>
@@ -5047,7 +4999,7 @@
               </a:defRPr>
             </a:pPr>
             <a:r>
-              <a:t>@Qualcomm Snapdragon® AI Lab Build &amp; Present Challenge 2026  |  Project: Kisan Sahayak AI  |  Developer: MOHD UBES                 Page 2</a:t>
+              <a:t>Project: Kisan Sahayak AI   |   Developer: MOHD UBES   |   Snapdragon® AI Lab Build &amp; Present Challenge 2026                 Page 2</a:t>
             </a:r>
           </a:p>
         </p:txBody>
@@ -5102,8 +5054,8 @@
         </p:nvSpPr>
         <p:spPr>
           <a:xfrm>
-            <a:off x="1645920" y="274320"/>
-            <a:ext cx="8046720" cy="868680"/>
+            <a:off x="1463040" y="274320"/>
+            <a:ext cx="10241280" cy="868680"/>
           </a:xfrm>
           <a:prstGeom prst="rect">
             <a:avLst/>
@@ -5117,7 +5069,7 @@
           <a:lstStyle/>
           <a:p>
             <a:pPr algn="ctr">
-              <a:defRPr sz="2100" b="1">
+              <a:defRPr sz="2200" b="1">
                 <a:solidFill>
                   <a:srgbClr val="0F172A"/>
                 </a:solidFill>
@@ -5130,13 +5082,345 @@
             <a:br/>
             <a:r>
               <a:t>Architecture, Snapdragon® NPU Acceleration &amp; Design Principles</a:t>
+            </a:r>
+          </a:p>
+        </p:txBody>
+      </p:sp>
+      <p:sp>
+        <p:nvSpPr>
+          <p:cNvPr id="4" name="Rectangle 3"/>
+          <p:cNvSpPr/>
+          <p:nvPr/>
+        </p:nvSpPr>
+        <p:spPr>
+          <a:xfrm>
+            <a:off x="457200" y="1234440"/>
+            <a:ext cx="11277295" cy="18288"/>
+          </a:xfrm>
+          <a:prstGeom prst="rect">
+            <a:avLst/>
+          </a:prstGeom>
+          <a:solidFill>
+            <a:srgbClr val="E2E8F0"/>
+          </a:solidFill>
+          <a:ln>
+            <a:solidFill>
+              <a:srgbClr val="E2E8F0"/>
+            </a:solidFill>
+          </a:ln>
+        </p:spPr>
+        <p:style>
+          <a:lnRef idx="1">
+            <a:schemeClr val="accent1"/>
+          </a:lnRef>
+          <a:fillRef idx="3">
+            <a:schemeClr val="accent1"/>
+          </a:fillRef>
+          <a:effectRef idx="2">
+            <a:schemeClr val="accent1"/>
+          </a:effectRef>
+          <a:fontRef idx="minor">
+            <a:schemeClr val="lt1"/>
+          </a:fontRef>
+        </p:style>
+        <p:txBody>
+          <a:bodyPr rtlCol="0" anchor="ctr"/>
+          <a:lstStyle/>
+          <a:p>
+            <a:pPr algn="ctr"/>
+          </a:p>
+        </p:txBody>
+      </p:sp>
+      <p:sp>
+        <p:nvSpPr>
+          <p:cNvPr id="5" name="Rounded Rectangle 4"/>
+          <p:cNvSpPr/>
+          <p:nvPr/>
+        </p:nvSpPr>
+        <p:spPr>
+          <a:xfrm>
+            <a:off x="548640" y="1371600"/>
+            <a:ext cx="4114800" cy="4937760"/>
+          </a:xfrm>
+          <a:prstGeom prst="roundRect">
+            <a:avLst/>
+          </a:prstGeom>
+          <a:solidFill>
+            <a:srgbClr val="FFFFFF"/>
+          </a:solidFill>
+          <a:ln w="19050">
+            <a:solidFill>
+              <a:srgbClr val="CBD5E1"/>
+            </a:solidFill>
+          </a:ln>
+        </p:spPr>
+        <p:style>
+          <a:lnRef idx="1">
+            <a:schemeClr val="accent1"/>
+          </a:lnRef>
+          <a:fillRef idx="3">
+            <a:schemeClr val="accent1"/>
+          </a:fillRef>
+          <a:effectRef idx="2">
+            <a:schemeClr val="accent1"/>
+          </a:effectRef>
+          <a:fontRef idx="minor">
+            <a:schemeClr val="lt1"/>
+          </a:fontRef>
+        </p:style>
+        <p:txBody>
+          <a:bodyPr rtlCol="0" anchor="ctr" wrap="square" lIns="228600" rIns="228600" tIns="182880"/>
+          <a:lstStyle/>
+          <a:p>
+            <a:pPr algn="ctr">
+              <a:spcAft>
+                <a:spcPts val="800"/>
+              </a:spcAft>
+              <a:defRPr b="1" sz="1300">
+                <a:solidFill>
+                  <a:srgbClr val="0F172A"/>
+                </a:solidFill>
+              </a:defRPr>
+            </a:pPr>
+            <a:r>
+              <a:t>Technology Stack</a:t>
+            </a:r>
+          </a:p>
+          <a:p>
+            <a:pPr>
+              <a:spcAft>
+                <a:spcPts val="400"/>
+              </a:spcAft>
+            </a:pPr>
+            <a:r>
+              <a:rPr b="1" sz="900">
+                <a:solidFill>
+                  <a:srgbClr val="0F172A"/>
+                </a:solidFill>
+              </a:rPr>
+              <a:t>• Frontend &amp; PWA: </a:t>
+            </a:r>
+            <a:r>
+              <a:rPr sz="850">
+                <a:solidFill>
+                  <a:srgbClr val="334155"/>
+                </a:solidFill>
+              </a:rPr>
+              <a:t>React 19, Tailwind CSS, Lucide Icons, Canvas Camera ROI</a:t>
+            </a:r>
+          </a:p>
+          <a:p>
+            <a:pPr>
+              <a:spcAft>
+                <a:spcPts val="400"/>
+              </a:spcAft>
+            </a:pPr>
+            <a:r>
+              <a:rPr b="1" sz="900">
+                <a:solidFill>
+                  <a:srgbClr val="0F172A"/>
+                </a:solidFill>
+              </a:rPr>
+              <a:t>• AI Runtime: </a:t>
+            </a:r>
+            <a:r>
+              <a:rPr sz="850">
+                <a:solidFill>
+                  <a:srgbClr val="334155"/>
+                </a:solidFill>
+              </a:rPr>
+              <a:t>ONNX Runtime Web with Qualcomm Hexagon NPU Provider</a:t>
+            </a:r>
+          </a:p>
+          <a:p>
+            <a:pPr>
+              <a:spcAft>
+                <a:spcPts val="400"/>
+              </a:spcAft>
+            </a:pPr>
+            <a:r>
+              <a:rPr b="1" sz="900">
+                <a:solidFill>
+                  <a:srgbClr val="0F172A"/>
+                </a:solidFill>
+              </a:rPr>
+              <a:t>• Vision Model: </a:t>
+            </a:r>
+            <a:r>
+              <a:rPr sz="850">
+                <a:solidFill>
+                  <a:srgbClr val="334155"/>
+                </a:solidFill>
+              </a:rPr>
+              <a:t>MobileNetV4 INT8 (38 plant pathology classes, &lt;18ms)</a:t>
+            </a:r>
+          </a:p>
+          <a:p>
+            <a:pPr>
+              <a:spcAft>
+                <a:spcPts val="400"/>
+              </a:spcAft>
+            </a:pPr>
+            <a:r>
+              <a:rPr b="1" sz="900">
+                <a:solidFill>
+                  <a:srgbClr val="0F172A"/>
+                </a:solidFill>
+              </a:rPr>
+              <a:t>• Voice Speech: </a:t>
+            </a:r>
+            <a:r>
+              <a:rPr sz="850">
+                <a:solidFill>
+                  <a:srgbClr val="334155"/>
+                </a:solidFill>
+              </a:rPr>
+              <a:t>Whisper Tiny INT8 (10+ Indic languages, zero latency)</a:t>
+            </a:r>
+          </a:p>
+          <a:p>
+            <a:pPr>
+              <a:spcAft>
+                <a:spcPts val="400"/>
+              </a:spcAft>
+            </a:pPr>
+            <a:r>
+              <a:rPr b="1" sz="900">
+                <a:solidFill>
+                  <a:srgbClr val="0F172A"/>
+                </a:solidFill>
+              </a:rPr>
+              <a:t>• Rule Engines: </a:t>
+            </a:r>
+            <a:r>
+              <a:rPr sz="850">
+                <a:solidFill>
+                  <a:srgbClr val="334155"/>
+                </a:solidFill>
+              </a:rPr>
+              <a:t>Deterministic fertilizer/pesticide dosage &amp; 15+ subsidy match</a:t>
+            </a:r>
+          </a:p>
+          <a:p>
+            <a:pPr>
+              <a:spcAft>
+                <a:spcPts val="400"/>
+              </a:spcAft>
+            </a:pPr>
+            <a:r>
+              <a:rPr b="1" sz="900">
+                <a:solidFill>
+                  <a:srgbClr val="0F172A"/>
+                </a:solidFill>
+              </a:rPr>
+              <a:t>• Mandi &amp; Weather: </a:t>
+            </a:r>
+            <a:r>
+              <a:rPr sz="850">
+                <a:solidFill>
+                  <a:srgbClr val="334155"/>
+                </a:solidFill>
+              </a:rPr>
+              <a:t>APMC 500+ Mandi rates + localized hourly weather alerts</a:t>
+            </a:r>
+          </a:p>
+          <a:p>
+            <a:pPr>
+              <a:spcAft>
+                <a:spcPts val="400"/>
+              </a:spcAft>
+            </a:pPr>
+            <a:r>
+              <a:rPr b="1" sz="900">
+                <a:solidFill>
+                  <a:srgbClr val="0F172A"/>
+                </a:solidFill>
+              </a:rPr>
+              <a:t>• Hardware: </a:t>
+            </a:r>
+            <a:r>
+              <a:rPr sz="850">
+                <a:solidFill>
+                  <a:srgbClr val="334155"/>
+                </a:solidFill>
+              </a:rPr>
+              <a:t>Qualcomm Snapdragon® X Elite (45 TOPS NPU, 4.2W power)</a:t>
+            </a:r>
+          </a:p>
+        </p:txBody>
+      </p:sp>
+      <p:sp>
+        <p:nvSpPr>
+          <p:cNvPr id="6" name="Rounded Rectangle 5"/>
+          <p:cNvSpPr/>
+          <p:nvPr/>
+        </p:nvSpPr>
+        <p:spPr>
+          <a:xfrm>
+            <a:off x="685800" y="4114800"/>
+            <a:ext cx="3840480" cy="2011680"/>
+          </a:xfrm>
+          <a:prstGeom prst="roundRect">
+            <a:avLst/>
+          </a:prstGeom>
+          <a:solidFill>
+            <a:srgbClr val="EFF6FF"/>
+          </a:solidFill>
+          <a:ln w="19050">
+            <a:solidFill>
+              <a:srgbClr val="2563EB"/>
+            </a:solidFill>
+          </a:ln>
+        </p:spPr>
+        <p:style>
+          <a:lnRef idx="1">
+            <a:schemeClr val="accent1"/>
+          </a:lnRef>
+          <a:fillRef idx="3">
+            <a:schemeClr val="accent1"/>
+          </a:fillRef>
+          <a:effectRef idx="2">
+            <a:schemeClr val="accent1"/>
+          </a:effectRef>
+          <a:fontRef idx="minor">
+            <a:schemeClr val="lt1"/>
+          </a:fontRef>
+        </p:style>
+        <p:txBody>
+          <a:bodyPr rtlCol="0" anchor="ctr" wrap="square" lIns="137160" rIns="137160" tIns="137160"/>
+          <a:lstStyle/>
+          <a:p>
+            <a:pPr algn="ctr">
+              <a:spcAft>
+                <a:spcPts val="400"/>
+              </a:spcAft>
+              <a:defRPr b="1" sz="950">
+                <a:solidFill>
+                  <a:srgbClr val="2563EB"/>
+                </a:solidFill>
+              </a:defRPr>
+            </a:pPr>
+            <a:r>
+              <a:t>CORE DESIGN PRINCIPLE: ZERO HALLUCINATION</a:t>
+            </a:r>
+          </a:p>
+          <a:p>
+            <a:pPr>
+              <a:defRPr sz="850">
+                <a:solidFill>
+                  <a:srgbClr val="334155"/>
+                </a:solidFill>
+              </a:defRPr>
+            </a:pPr>
+            <a:r>
+              <a:t>All crop disease arithmetic, chemical concentrations, and government scheme eligibility run on deterministic rule-based code. The AI model is strictly used for computer vision and Indic voice transcription—ensuring 100% auditability and zero dangerous pesticide dosage advice.</a:t>
             </a:r>
           </a:p>
         </p:txBody>
       </p:sp>
       <p:pic>
         <p:nvPicPr>
-          <p:cNvPr id="4" name="Picture 3" descr="challenge_logo.png"/>
+          <p:cNvPr id="7" name="Picture 6" descr="slide3_architecture.png"/>
           <p:cNvPicPr>
             <a:picLocks noChangeAspect="1"/>
           </p:cNvPicPr>
@@ -5150,8 +5434,8 @@
         </p:blipFill>
         <p:spPr>
           <a:xfrm>
-            <a:off x="10058400" y="228600"/>
-            <a:ext cx="1645920" cy="914400"/>
+            <a:off x="4846320" y="1371600"/>
+            <a:ext cx="6766560" cy="4937760"/>
           </a:xfrm>
           <a:prstGeom prst="rect">
             <a:avLst/>
@@ -5160,363 +5444,7 @@
       </p:pic>
       <p:sp>
         <p:nvSpPr>
-          <p:cNvPr id="5" name="Rectangle 4"/>
-          <p:cNvSpPr/>
-          <p:nvPr/>
-        </p:nvSpPr>
-        <p:spPr>
-          <a:xfrm>
-            <a:off x="457200" y="1234440"/>
-            <a:ext cx="11277295" cy="18288"/>
-          </a:xfrm>
-          <a:prstGeom prst="rect">
-            <a:avLst/>
-          </a:prstGeom>
-          <a:solidFill>
-            <a:srgbClr val="E2E8F0"/>
-          </a:solidFill>
-          <a:ln>
-            <a:solidFill>
-              <a:srgbClr val="E2E8F0"/>
-            </a:solidFill>
-          </a:ln>
-        </p:spPr>
-        <p:style>
-          <a:lnRef idx="1">
-            <a:schemeClr val="accent1"/>
-          </a:lnRef>
-          <a:fillRef idx="3">
-            <a:schemeClr val="accent1"/>
-          </a:fillRef>
-          <a:effectRef idx="2">
-            <a:schemeClr val="accent1"/>
-          </a:effectRef>
-          <a:fontRef idx="minor">
-            <a:schemeClr val="lt1"/>
-          </a:fontRef>
-        </p:style>
-        <p:txBody>
-          <a:bodyPr rtlCol="0" anchor="ctr"/>
-          <a:lstStyle/>
-          <a:p>
-            <a:pPr algn="ctr"/>
-          </a:p>
-        </p:txBody>
-      </p:sp>
-      <p:sp>
-        <p:nvSpPr>
-          <p:cNvPr id="6" name="Rounded Rectangle 5"/>
-          <p:cNvSpPr/>
-          <p:nvPr/>
-        </p:nvSpPr>
-        <p:spPr>
-          <a:xfrm>
-            <a:off x="548640" y="1371600"/>
-            <a:ext cx="4114800" cy="4937760"/>
-          </a:xfrm>
-          <a:prstGeom prst="roundRect">
-            <a:avLst/>
-          </a:prstGeom>
-          <a:solidFill>
-            <a:srgbClr val="FFFFFF"/>
-          </a:solidFill>
-          <a:ln w="19050">
-            <a:solidFill>
-              <a:srgbClr val="CBD5E1"/>
-            </a:solidFill>
-          </a:ln>
-        </p:spPr>
-        <p:style>
-          <a:lnRef idx="1">
-            <a:schemeClr val="accent1"/>
-          </a:lnRef>
-          <a:fillRef idx="3">
-            <a:schemeClr val="accent1"/>
-          </a:fillRef>
-          <a:effectRef idx="2">
-            <a:schemeClr val="accent1"/>
-          </a:effectRef>
-          <a:fontRef idx="minor">
-            <a:schemeClr val="lt1"/>
-          </a:fontRef>
-        </p:style>
-        <p:txBody>
-          <a:bodyPr rtlCol="0" anchor="ctr" wrap="square" lIns="228600" rIns="228600" tIns="182880"/>
-          <a:lstStyle/>
-          <a:p>
-            <a:pPr algn="ctr">
-              <a:spcAft>
-                <a:spcPts val="800"/>
-              </a:spcAft>
-              <a:defRPr b="1" sz="1300">
-                <a:solidFill>
-                  <a:srgbClr val="0F172A"/>
-                </a:solidFill>
-              </a:defRPr>
-            </a:pPr>
-            <a:r>
-              <a:t>Technology Stack</a:t>
-            </a:r>
-          </a:p>
-          <a:p>
-            <a:pPr>
-              <a:spcAft>
-                <a:spcPts val="400"/>
-              </a:spcAft>
-            </a:pPr>
-            <a:r>
-              <a:rPr b="1" sz="900">
-                <a:solidFill>
-                  <a:srgbClr val="0F172A"/>
-                </a:solidFill>
-              </a:rPr>
-              <a:t>• Frontend &amp; PWA: </a:t>
-            </a:r>
-            <a:r>
-              <a:rPr sz="850">
-                <a:solidFill>
-                  <a:srgbClr val="334155"/>
-                </a:solidFill>
-              </a:rPr>
-              <a:t>React 19, Tailwind CSS, Lucide Icons, Canvas Camera ROI</a:t>
-            </a:r>
-          </a:p>
-          <a:p>
-            <a:pPr>
-              <a:spcAft>
-                <a:spcPts val="400"/>
-              </a:spcAft>
-            </a:pPr>
-            <a:r>
-              <a:rPr b="1" sz="900">
-                <a:solidFill>
-                  <a:srgbClr val="0F172A"/>
-                </a:solidFill>
-              </a:rPr>
-              <a:t>• AI Runtime: </a:t>
-            </a:r>
-            <a:r>
-              <a:rPr sz="850">
-                <a:solidFill>
-                  <a:srgbClr val="334155"/>
-                </a:solidFill>
-              </a:rPr>
-              <a:t>ONNX Runtime Web with Qualcomm Hexagon NPU Provider</a:t>
-            </a:r>
-          </a:p>
-          <a:p>
-            <a:pPr>
-              <a:spcAft>
-                <a:spcPts val="400"/>
-              </a:spcAft>
-            </a:pPr>
-            <a:r>
-              <a:rPr b="1" sz="900">
-                <a:solidFill>
-                  <a:srgbClr val="0F172A"/>
-                </a:solidFill>
-              </a:rPr>
-              <a:t>• Vision Model: </a:t>
-            </a:r>
-            <a:r>
-              <a:rPr sz="850">
-                <a:solidFill>
-                  <a:srgbClr val="334155"/>
-                </a:solidFill>
-              </a:rPr>
-              <a:t>MobileNetV4 INT8 (38 plant pathology classes, &lt;18ms)</a:t>
-            </a:r>
-          </a:p>
-          <a:p>
-            <a:pPr>
-              <a:spcAft>
-                <a:spcPts val="400"/>
-              </a:spcAft>
-            </a:pPr>
-            <a:r>
-              <a:rPr b="1" sz="900">
-                <a:solidFill>
-                  <a:srgbClr val="0F172A"/>
-                </a:solidFill>
-              </a:rPr>
-              <a:t>• Voice Speech: </a:t>
-            </a:r>
-            <a:r>
-              <a:rPr sz="850">
-                <a:solidFill>
-                  <a:srgbClr val="334155"/>
-                </a:solidFill>
-              </a:rPr>
-              <a:t>Whisper Tiny INT8 (10+ Indic languages, zero latency)</a:t>
-            </a:r>
-          </a:p>
-          <a:p>
-            <a:pPr>
-              <a:spcAft>
-                <a:spcPts val="400"/>
-              </a:spcAft>
-            </a:pPr>
-            <a:r>
-              <a:rPr b="1" sz="900">
-                <a:solidFill>
-                  <a:srgbClr val="0F172A"/>
-                </a:solidFill>
-              </a:rPr>
-              <a:t>• Rule Engines: </a:t>
-            </a:r>
-            <a:r>
-              <a:rPr sz="850">
-                <a:solidFill>
-                  <a:srgbClr val="334155"/>
-                </a:solidFill>
-              </a:rPr>
-              <a:t>Deterministic fertilizer/pesticide dosage &amp; 15+ subsidy match</a:t>
-            </a:r>
-          </a:p>
-          <a:p>
-            <a:pPr>
-              <a:spcAft>
-                <a:spcPts val="400"/>
-              </a:spcAft>
-            </a:pPr>
-            <a:r>
-              <a:rPr b="1" sz="900">
-                <a:solidFill>
-                  <a:srgbClr val="0F172A"/>
-                </a:solidFill>
-              </a:rPr>
-              <a:t>• Mandi &amp; Weather: </a:t>
-            </a:r>
-            <a:r>
-              <a:rPr sz="850">
-                <a:solidFill>
-                  <a:srgbClr val="334155"/>
-                </a:solidFill>
-              </a:rPr>
-              <a:t>APMC 500+ Mandi rates + localized hourly weather alerts</a:t>
-            </a:r>
-          </a:p>
-          <a:p>
-            <a:pPr>
-              <a:spcAft>
-                <a:spcPts val="400"/>
-              </a:spcAft>
-            </a:pPr>
-            <a:r>
-              <a:rPr b="1" sz="900">
-                <a:solidFill>
-                  <a:srgbClr val="0F172A"/>
-                </a:solidFill>
-              </a:rPr>
-              <a:t>• Hardware: </a:t>
-            </a:r>
-            <a:r>
-              <a:rPr sz="850">
-                <a:solidFill>
-                  <a:srgbClr val="334155"/>
-                </a:solidFill>
-              </a:rPr>
-              <a:t>Qualcomm Snapdragon® X Elite (45 TOPS NPU, 4.2W power)</a:t>
-            </a:r>
-          </a:p>
-        </p:txBody>
-      </p:sp>
-      <p:sp>
-        <p:nvSpPr>
-          <p:cNvPr id="7" name="Rounded Rectangle 6"/>
-          <p:cNvSpPr/>
-          <p:nvPr/>
-        </p:nvSpPr>
-        <p:spPr>
-          <a:xfrm>
-            <a:off x="685800" y="4114800"/>
-            <a:ext cx="3840480" cy="2011680"/>
-          </a:xfrm>
-          <a:prstGeom prst="roundRect">
-            <a:avLst/>
-          </a:prstGeom>
-          <a:solidFill>
-            <a:srgbClr val="EFF6FF"/>
-          </a:solidFill>
-          <a:ln w="19050">
-            <a:solidFill>
-              <a:srgbClr val="2563EB"/>
-            </a:solidFill>
-          </a:ln>
-        </p:spPr>
-        <p:style>
-          <a:lnRef idx="1">
-            <a:schemeClr val="accent1"/>
-          </a:lnRef>
-          <a:fillRef idx="3">
-            <a:schemeClr val="accent1"/>
-          </a:fillRef>
-          <a:effectRef idx="2">
-            <a:schemeClr val="accent1"/>
-          </a:effectRef>
-          <a:fontRef idx="minor">
-            <a:schemeClr val="lt1"/>
-          </a:fontRef>
-        </p:style>
-        <p:txBody>
-          <a:bodyPr rtlCol="0" anchor="ctr" wrap="square" lIns="137160" rIns="137160" tIns="137160"/>
-          <a:lstStyle/>
-          <a:p>
-            <a:pPr algn="ctr">
-              <a:spcAft>
-                <a:spcPts val="400"/>
-              </a:spcAft>
-              <a:defRPr b="1" sz="950">
-                <a:solidFill>
-                  <a:srgbClr val="2563EB"/>
-                </a:solidFill>
-              </a:defRPr>
-            </a:pPr>
-            <a:r>
-              <a:t>CORE DESIGN PRINCIPLE: ZERO HALLUCINATION</a:t>
-            </a:r>
-          </a:p>
-          <a:p>
-            <a:pPr>
-              <a:defRPr sz="850">
-                <a:solidFill>
-                  <a:srgbClr val="334155"/>
-                </a:solidFill>
-              </a:defRPr>
-            </a:pPr>
-            <a:r>
-              <a:t>All crop disease arithmetic, chemical concentrations, and government scheme eligibility run on deterministic rule-based code. The AI model is strictly used for computer vision and Indic voice transcription—ensuring 100% auditability and zero dangerous pesticide dosage advice.</a:t>
-            </a:r>
-          </a:p>
-        </p:txBody>
-      </p:sp>
-      <p:pic>
-        <p:nvPicPr>
-          <p:cNvPr id="8" name="Picture 7" descr="slide3_architecture.png"/>
-          <p:cNvPicPr>
-            <a:picLocks noChangeAspect="1"/>
-          </p:cNvPicPr>
-          <p:nvPr/>
-        </p:nvPicPr>
-        <p:blipFill>
-          <a:blip r:embed="rId4"/>
-          <a:stretch>
-            <a:fillRect/>
-          </a:stretch>
-        </p:blipFill>
-        <p:spPr>
-          <a:xfrm>
-            <a:off x="4846320" y="1371600"/>
-            <a:ext cx="6766560" cy="4937760"/>
-          </a:xfrm>
-          <a:prstGeom prst="rect">
-            <a:avLst/>
-          </a:prstGeom>
-        </p:spPr>
-      </p:pic>
-      <p:sp>
-        <p:nvSpPr>
-          <p:cNvPr id="9" name="Rectangle 8"/>
+          <p:cNvPr id="8" name="Rectangle 7"/>
           <p:cNvSpPr/>
           <p:nvPr/>
         </p:nvSpPr>
@@ -5562,7 +5490,7 @@
               </a:defRPr>
             </a:pPr>
             <a:r>
-              <a:t>@Qualcomm Snapdragon® AI Lab Build &amp; Present Challenge 2026  |  Project: Kisan Sahayak AI  |  Developer: MOHD UBES                 Page 3</a:t>
+              <a:t>Project: Kisan Sahayak AI   |   Developer: MOHD UBES   |   Snapdragon® AI Lab Build &amp; Present Challenge 2026                 Page 3</a:t>
             </a:r>
           </a:p>
         </p:txBody>
@@ -5617,8 +5545,8 @@
         </p:nvSpPr>
         <p:spPr>
           <a:xfrm>
-            <a:off x="1645920" y="274320"/>
-            <a:ext cx="8046720" cy="868680"/>
+            <a:off x="1463040" y="274320"/>
+            <a:ext cx="10241280" cy="868680"/>
           </a:xfrm>
           <a:prstGeom prst="rect">
             <a:avLst/>
@@ -5632,7 +5560,7 @@
           <a:lstStyle/>
           <a:p>
             <a:pPr algn="ctr">
-              <a:defRPr sz="2100" b="1">
+              <a:defRPr sz="2200" b="1">
                 <a:solidFill>
                   <a:srgbClr val="0F172A"/>
                 </a:solidFill>
@@ -5646,12 +5574,57 @@
             <a:r>
               <a:t>Hierarchical Solution Analysis, Operational Viability &amp; Mitigation Strategies</a:t>
             </a:r>
+          </a:p>
+        </p:txBody>
+      </p:sp>
+      <p:sp>
+        <p:nvSpPr>
+          <p:cNvPr id="4" name="Rectangle 3"/>
+          <p:cNvSpPr/>
+          <p:nvPr/>
+        </p:nvSpPr>
+        <p:spPr>
+          <a:xfrm>
+            <a:off x="457200" y="1234440"/>
+            <a:ext cx="11277295" cy="18288"/>
+          </a:xfrm>
+          <a:prstGeom prst="rect">
+            <a:avLst/>
+          </a:prstGeom>
+          <a:solidFill>
+            <a:srgbClr val="E2E8F0"/>
+          </a:solidFill>
+          <a:ln>
+            <a:solidFill>
+              <a:srgbClr val="E2E8F0"/>
+            </a:solidFill>
+          </a:ln>
+        </p:spPr>
+        <p:style>
+          <a:lnRef idx="1">
+            <a:schemeClr val="accent1"/>
+          </a:lnRef>
+          <a:fillRef idx="3">
+            <a:schemeClr val="accent1"/>
+          </a:fillRef>
+          <a:effectRef idx="2">
+            <a:schemeClr val="accent1"/>
+          </a:effectRef>
+          <a:fontRef idx="minor">
+            <a:schemeClr val="lt1"/>
+          </a:fontRef>
+        </p:style>
+        <p:txBody>
+          <a:bodyPr rtlCol="0" anchor="ctr"/>
+          <a:lstStyle/>
+          <a:p>
+            <a:pPr algn="ctr"/>
           </a:p>
         </p:txBody>
       </p:sp>
       <p:pic>
         <p:nvPicPr>
-          <p:cNvPr id="4" name="Picture 3" descr="challenge_logo.png"/>
+          <p:cNvPr id="5" name="Picture 4" descr="slide4_tree.png"/>
           <p:cNvPicPr>
             <a:picLocks noChangeAspect="1"/>
           </p:cNvPicPr>
@@ -5665,8 +5638,8 @@
         </p:blipFill>
         <p:spPr>
           <a:xfrm>
-            <a:off x="10058400" y="228600"/>
-            <a:ext cx="1645920" cy="914400"/>
+            <a:off x="548640" y="1371600"/>
+            <a:ext cx="11094415" cy="4937760"/>
           </a:xfrm>
           <a:prstGeom prst="rect">
             <a:avLst/>
@@ -5675,76 +5648,7 @@
       </p:pic>
       <p:sp>
         <p:nvSpPr>
-          <p:cNvPr id="5" name="Rectangle 4"/>
-          <p:cNvSpPr/>
-          <p:nvPr/>
-        </p:nvSpPr>
-        <p:spPr>
-          <a:xfrm>
-            <a:off x="457200" y="1234440"/>
-            <a:ext cx="11277295" cy="18288"/>
-          </a:xfrm>
-          <a:prstGeom prst="rect">
-            <a:avLst/>
-          </a:prstGeom>
-          <a:solidFill>
-            <a:srgbClr val="E2E8F0"/>
-          </a:solidFill>
-          <a:ln>
-            <a:solidFill>
-              <a:srgbClr val="E2E8F0"/>
-            </a:solidFill>
-          </a:ln>
-        </p:spPr>
-        <p:style>
-          <a:lnRef idx="1">
-            <a:schemeClr val="accent1"/>
-          </a:lnRef>
-          <a:fillRef idx="3">
-            <a:schemeClr val="accent1"/>
-          </a:fillRef>
-          <a:effectRef idx="2">
-            <a:schemeClr val="accent1"/>
-          </a:effectRef>
-          <a:fontRef idx="minor">
-            <a:schemeClr val="lt1"/>
-          </a:fontRef>
-        </p:style>
-        <p:txBody>
-          <a:bodyPr rtlCol="0" anchor="ctr"/>
-          <a:lstStyle/>
-          <a:p>
-            <a:pPr algn="ctr"/>
-          </a:p>
-        </p:txBody>
-      </p:sp>
-      <p:pic>
-        <p:nvPicPr>
-          <p:cNvPr id="6" name="Picture 5" descr="slide4_tree.png"/>
-          <p:cNvPicPr>
-            <a:picLocks noChangeAspect="1"/>
-          </p:cNvPicPr>
-          <p:nvPr/>
-        </p:nvPicPr>
-        <p:blipFill>
-          <a:blip r:embed="rId4"/>
-          <a:stretch>
-            <a:fillRect/>
-          </a:stretch>
-        </p:blipFill>
-        <p:spPr>
-          <a:xfrm>
-            <a:off x="548640" y="1371600"/>
-            <a:ext cx="11094415" cy="4937760"/>
-          </a:xfrm>
-          <a:prstGeom prst="rect">
-            <a:avLst/>
-          </a:prstGeom>
-        </p:spPr>
-      </p:pic>
-      <p:sp>
-        <p:nvSpPr>
-          <p:cNvPr id="7" name="Rectangle 6"/>
+          <p:cNvPr id="6" name="Rectangle 5"/>
           <p:cNvSpPr/>
           <p:nvPr/>
         </p:nvSpPr>
@@ -5790,7 +5694,7 @@
               </a:defRPr>
             </a:pPr>
             <a:r>
-              <a:t>@Qualcomm Snapdragon® AI Lab Build &amp; Present Challenge 2026  |  Project: Kisan Sahayak AI  |  Developer: MOHD UBES                 Page 4</a:t>
+              <a:t>Project: Kisan Sahayak AI   |   Developer: MOHD UBES   |   Snapdragon® AI Lab Build &amp; Present Challenge 2026                 Page 4</a:t>
             </a:r>
           </a:p>
         </p:txBody>
@@ -5845,8 +5749,8 @@
         </p:nvSpPr>
         <p:spPr>
           <a:xfrm>
-            <a:off x="1645920" y="274320"/>
-            <a:ext cx="8046720" cy="868680"/>
+            <a:off x="1463040" y="274320"/>
+            <a:ext cx="10241280" cy="868680"/>
           </a:xfrm>
           <a:prstGeom prst="rect">
             <a:avLst/>
@@ -5860,7 +5764,7 @@
           <a:lstStyle/>
           <a:p>
             <a:pPr algn="ctr">
-              <a:defRPr sz="2100" b="1">
+              <a:defRPr sz="2200" b="1">
                 <a:solidFill>
                   <a:srgbClr val="0F172A"/>
                 </a:solidFill>
@@ -5874,12 +5778,102 @@
             <a:r>
               <a:t>Quantifiable Agronomic Gains, Inclusion &amp; Measurable Socio-Economic Value</a:t>
             </a:r>
+          </a:p>
+        </p:txBody>
+      </p:sp>
+      <p:sp>
+        <p:nvSpPr>
+          <p:cNvPr id="4" name="Rectangle 3"/>
+          <p:cNvSpPr/>
+          <p:nvPr/>
+        </p:nvSpPr>
+        <p:spPr>
+          <a:xfrm>
+            <a:off x="457200" y="1234440"/>
+            <a:ext cx="11277295" cy="18288"/>
+          </a:xfrm>
+          <a:prstGeom prst="rect">
+            <a:avLst/>
+          </a:prstGeom>
+          <a:solidFill>
+            <a:srgbClr val="E2E8F0"/>
+          </a:solidFill>
+          <a:ln>
+            <a:solidFill>
+              <a:srgbClr val="E2E8F0"/>
+            </a:solidFill>
+          </a:ln>
+        </p:spPr>
+        <p:style>
+          <a:lnRef idx="1">
+            <a:schemeClr val="accent1"/>
+          </a:lnRef>
+          <a:fillRef idx="3">
+            <a:schemeClr val="accent1"/>
+          </a:fillRef>
+          <a:effectRef idx="2">
+            <a:schemeClr val="accent1"/>
+          </a:effectRef>
+          <a:fontRef idx="minor">
+            <a:schemeClr val="lt1"/>
+          </a:fontRef>
+        </p:style>
+        <p:txBody>
+          <a:bodyPr rtlCol="0" anchor="ctr"/>
+          <a:lstStyle/>
+          <a:p>
+            <a:pPr algn="ctr"/>
+          </a:p>
+        </p:txBody>
+      </p:sp>
+      <p:sp>
+        <p:nvSpPr>
+          <p:cNvPr id="5" name="Rounded Rectangle 4"/>
+          <p:cNvSpPr/>
+          <p:nvPr/>
+        </p:nvSpPr>
+        <p:spPr>
+          <a:xfrm>
+            <a:off x="548640" y="1371600"/>
+            <a:ext cx="3566160" cy="2057400"/>
+          </a:xfrm>
+          <a:prstGeom prst="roundRect">
+            <a:avLst/>
+          </a:prstGeom>
+          <a:solidFill>
+            <a:srgbClr val="EFF6FF"/>
+          </a:solidFill>
+          <a:ln w="19050">
+            <a:solidFill>
+              <a:srgbClr val="2563EB"/>
+            </a:solidFill>
+          </a:ln>
+        </p:spPr>
+        <p:style>
+          <a:lnRef idx="1">
+            <a:schemeClr val="accent1"/>
+          </a:lnRef>
+          <a:fillRef idx="3">
+            <a:schemeClr val="accent1"/>
+          </a:fillRef>
+          <a:effectRef idx="2">
+            <a:schemeClr val="accent1"/>
+          </a:effectRef>
+          <a:fontRef idx="minor">
+            <a:schemeClr val="lt1"/>
+          </a:fontRef>
+        </p:style>
+        <p:txBody>
+          <a:bodyPr rtlCol="0" anchor="ctr"/>
+          <a:lstStyle/>
+          <a:p>
+            <a:pPr algn="ctr"/>
           </a:p>
         </p:txBody>
       </p:sp>
       <p:pic>
         <p:nvPicPr>
-          <p:cNvPr id="4" name="Picture 3" descr="challenge_logo.png"/>
+          <p:cNvPr id="6" name="Picture 5" descr="icon_financial.png"/>
           <p:cNvPicPr>
             <a:picLocks noChangeAspect="1"/>
           </p:cNvPicPr>
@@ -5893,8 +5887,8 @@
         </p:blipFill>
         <p:spPr>
           <a:xfrm>
-            <a:off x="10058400" y="228600"/>
-            <a:ext cx="1645920" cy="914400"/>
+            <a:off x="685800" y="1600200"/>
+            <a:ext cx="1051560" cy="1051560"/>
           </a:xfrm>
           <a:prstGeom prst="rect">
             <a:avLst/>
@@ -5903,24 +5897,76 @@
       </p:pic>
       <p:sp>
         <p:nvSpPr>
-          <p:cNvPr id="5" name="Rectangle 4"/>
-          <p:cNvSpPr/>
+          <p:cNvPr id="7" name="TextBox 6"/>
+          <p:cNvSpPr txBox="1"/>
           <p:nvPr/>
         </p:nvSpPr>
         <p:spPr>
           <a:xfrm>
-            <a:off x="457200" y="1234440"/>
-            <a:ext cx="11277295" cy="18288"/>
+            <a:off x="1783080" y="1508760"/>
+            <a:ext cx="2240280" cy="1783080"/>
           </a:xfrm>
           <a:prstGeom prst="rect">
             <a:avLst/>
           </a:prstGeom>
+          <a:noFill/>
+        </p:spPr>
+        <p:txBody>
+          <a:bodyPr wrap="square">
+            <a:spAutoFit/>
+          </a:bodyPr>
+          <a:lstStyle/>
+          <a:p>
+            <a:pPr>
+              <a:spcAft>
+                <a:spcPts val="400"/>
+              </a:spcAft>
+              <a:defRPr sz="1050" b="1">
+                <a:solidFill>
+                  <a:srgbClr val="2563EB"/>
+                </a:solidFill>
+                <a:latin typeface="Arial"/>
+              </a:defRPr>
+            </a:pPr>
+            <a:r>
+              <a:t>Financial Clarity &amp; Yield Gain</a:t>
+            </a:r>
+          </a:p>
+          <a:p>
+            <a:pPr>
+              <a:defRPr sz="850">
+                <a:solidFill>
+                  <a:srgbClr val="334155"/>
+                </a:solidFill>
+                <a:latin typeface="Arial"/>
+              </a:defRPr>
+            </a:pPr>
+            <a:r>
+              <a:t>Saves ₹12,000 – ₹18,000/acre by averting catastrophic blight outbreaks. Precise spray guidance cuts unnecessary pesticide expenditure by ₹3,500/season.</a:t>
+            </a:r>
+          </a:p>
+        </p:txBody>
+      </p:sp>
+      <p:sp>
+        <p:nvSpPr>
+          <p:cNvPr id="8" name="Rounded Rectangle 7"/>
+          <p:cNvSpPr/>
+          <p:nvPr/>
+        </p:nvSpPr>
+        <p:spPr>
+          <a:xfrm>
+            <a:off x="4343400" y="1371600"/>
+            <a:ext cx="3566160" cy="2057400"/>
+          </a:xfrm>
+          <a:prstGeom prst="roundRect">
+            <a:avLst/>
+          </a:prstGeom>
           <a:solidFill>
-            <a:srgbClr val="E2E8F0"/>
+            <a:srgbClr val="FEF2F2"/>
           </a:solidFill>
-          <a:ln>
+          <a:ln w="19050">
             <a:solidFill>
-              <a:srgbClr val="E2E8F0"/>
+              <a:srgbClr val="DC2626"/>
             </a:solidFill>
           </a:ln>
         </p:spPr>
@@ -5946,54 +5992,9 @@
           </a:p>
         </p:txBody>
       </p:sp>
-      <p:sp>
-        <p:nvSpPr>
-          <p:cNvPr id="6" name="Rounded Rectangle 5"/>
-          <p:cNvSpPr/>
-          <p:nvPr/>
-        </p:nvSpPr>
-        <p:spPr>
-          <a:xfrm>
-            <a:off x="548640" y="1371600"/>
-            <a:ext cx="3566160" cy="2057400"/>
-          </a:xfrm>
-          <a:prstGeom prst="roundRect">
-            <a:avLst/>
-          </a:prstGeom>
-          <a:solidFill>
-            <a:srgbClr val="EFF6FF"/>
-          </a:solidFill>
-          <a:ln w="19050">
-            <a:solidFill>
-              <a:srgbClr val="2563EB"/>
-            </a:solidFill>
-          </a:ln>
-        </p:spPr>
-        <p:style>
-          <a:lnRef idx="1">
-            <a:schemeClr val="accent1"/>
-          </a:lnRef>
-          <a:fillRef idx="3">
-            <a:schemeClr val="accent1"/>
-          </a:fillRef>
-          <a:effectRef idx="2">
-            <a:schemeClr val="accent1"/>
-          </a:effectRef>
-          <a:fontRef idx="minor">
-            <a:schemeClr val="lt1"/>
-          </a:fontRef>
-        </p:style>
-        <p:txBody>
-          <a:bodyPr rtlCol="0" anchor="ctr"/>
-          <a:lstStyle/>
-          <a:p>
-            <a:pPr algn="ctr"/>
-          </a:p>
-        </p:txBody>
-      </p:sp>
       <p:pic>
         <p:nvPicPr>
-          <p:cNvPr id="7" name="Picture 6" descr="icon_financial.png"/>
+          <p:cNvPr id="9" name="Picture 8" descr="icon_scheme.png"/>
           <p:cNvPicPr>
             <a:picLocks noChangeAspect="1"/>
           </p:cNvPicPr>
@@ -6007,7 +6008,7 @@
         </p:blipFill>
         <p:spPr>
           <a:xfrm>
-            <a:off x="685800" y="1600200"/>
+            <a:off x="4480560" y="1600200"/>
             <a:ext cx="1051560" cy="1051560"/>
           </a:xfrm>
           <a:prstGeom prst="rect">
@@ -6017,13 +6018,13 @@
       </p:pic>
       <p:sp>
         <p:nvSpPr>
-          <p:cNvPr id="8" name="TextBox 7"/>
+          <p:cNvPr id="10" name="TextBox 9"/>
           <p:cNvSpPr txBox="1"/>
           <p:nvPr/>
         </p:nvSpPr>
         <p:spPr>
           <a:xfrm>
-            <a:off x="1783080" y="1508760"/>
+            <a:off x="5577840" y="1508760"/>
             <a:ext cx="2240280" cy="1783080"/>
           </a:xfrm>
           <a:prstGeom prst="rect">
@@ -6043,13 +6044,13 @@
               </a:spcAft>
               <a:defRPr sz="1050" b="1">
                 <a:solidFill>
-                  <a:srgbClr val="2563EB"/>
+                  <a:srgbClr val="DC2626"/>
                 </a:solidFill>
                 <a:latin typeface="Arial"/>
               </a:defRPr>
             </a:pPr>
             <a:r>
-              <a:t>Financial Clarity &amp; Yield Gain</a:t>
+              <a:t>Direct Access to Subsidies</a:t>
             </a:r>
           </a:p>
           <a:p>
@@ -6062,31 +6063,31 @@
               </a:defRPr>
             </a:pPr>
             <a:r>
-              <a:t>Saves ₹12,000 – ₹18,000/acre by averting catastrophic blight outbreaks. Precise spray guidance cuts unnecessary pesticide expenditure by ₹3,500/season.</a:t>
-            </a:r>
-          </a:p>
-        </p:txBody>
-      </p:sp>
-      <p:sp>
-        <p:nvSpPr>
-          <p:cNvPr id="9" name="Rounded Rectangle 8"/>
+              <a:t>Auto-matches 15+ Central &amp; State schemes (PM-KISAN, PMFBY, PM-KUSUM 90% solar pump, SMAM 50-80% farm mechanization) with instant eligibility checklist.</a:t>
+            </a:r>
+          </a:p>
+        </p:txBody>
+      </p:sp>
+      <p:sp>
+        <p:nvSpPr>
+          <p:cNvPr id="11" name="Rounded Rectangle 10"/>
           <p:cNvSpPr/>
           <p:nvPr/>
         </p:nvSpPr>
         <p:spPr>
           <a:xfrm>
-            <a:off x="4343400" y="1371600"/>
+            <a:off x="8138160" y="1371600"/>
             <a:ext cx="3566160" cy="2057400"/>
           </a:xfrm>
           <a:prstGeom prst="roundRect">
             <a:avLst/>
           </a:prstGeom>
           <a:solidFill>
-            <a:srgbClr val="FEF2F2"/>
+            <a:srgbClr val="F0FDF4"/>
           </a:solidFill>
           <a:ln w="19050">
             <a:solidFill>
-              <a:srgbClr val="DC2626"/>
+              <a:srgbClr val="059669"/>
             </a:solidFill>
           </a:ln>
         </p:spPr>
@@ -6114,7 +6115,7 @@
       </p:sp>
       <p:pic>
         <p:nvPicPr>
-          <p:cNvPr id="10" name="Picture 9" descr="icon_scheme.png"/>
+          <p:cNvPr id="12" name="Picture 11" descr="icon_whatsapp.png"/>
           <p:cNvPicPr>
             <a:picLocks noChangeAspect="1"/>
           </p:cNvPicPr>
@@ -6128,7 +6129,7 @@
         </p:blipFill>
         <p:spPr>
           <a:xfrm>
-            <a:off x="4480560" y="1600200"/>
+            <a:off x="8275320" y="1600200"/>
             <a:ext cx="1051560" cy="1051560"/>
           </a:xfrm>
           <a:prstGeom prst="rect">
@@ -6138,13 +6139,13 @@
       </p:pic>
       <p:sp>
         <p:nvSpPr>
-          <p:cNvPr id="11" name="TextBox 10"/>
+          <p:cNvPr id="13" name="TextBox 12"/>
           <p:cNvSpPr txBox="1"/>
           <p:nvPr/>
         </p:nvSpPr>
         <p:spPr>
           <a:xfrm>
-            <a:off x="5577840" y="1508760"/>
+            <a:off x="9372600" y="1508760"/>
             <a:ext cx="2240280" cy="1783080"/>
           </a:xfrm>
           <a:prstGeom prst="rect">
@@ -6164,13 +6165,13 @@
               </a:spcAft>
               <a:defRPr sz="1050" b="1">
                 <a:solidFill>
-                  <a:srgbClr val="DC2626"/>
+                  <a:srgbClr val="059669"/>
                 </a:solidFill>
                 <a:latin typeface="Arial"/>
               </a:defRPr>
             </a:pPr>
             <a:r>
-              <a:t>Direct Access to Subsidies</a:t>
+              <a:t>Inclusive Multichannel Access</a:t>
             </a:r>
           </a:p>
           <a:p>
@@ -6183,31 +6184,31 @@
               </a:defRPr>
             </a:pPr>
             <a:r>
-              <a:t>Auto-matches 15+ Central &amp; State schemes (PM-KISAN, PMFBY, PM-KUSUM 90% solar pump, SMAM 50-80% farm mechanization) with instant eligibility checklist.</a:t>
-            </a:r>
-          </a:p>
-        </p:txBody>
-      </p:sp>
-      <p:sp>
-        <p:nvSpPr>
-          <p:cNvPr id="12" name="Rounded Rectangle 11"/>
+              <a:t>Zero barrier adoption: works via WhatsApp Bot, SMS fallback, and multilingual voice speech in 10+ Indic languages. No high digital literacy needed.</a:t>
+            </a:r>
+          </a:p>
+        </p:txBody>
+      </p:sp>
+      <p:sp>
+        <p:nvSpPr>
+          <p:cNvPr id="14" name="Rounded Rectangle 13"/>
           <p:cNvSpPr/>
           <p:nvPr/>
         </p:nvSpPr>
         <p:spPr>
           <a:xfrm>
-            <a:off x="8138160" y="1371600"/>
+            <a:off x="548640" y="3611880"/>
             <a:ext cx="3566160" cy="2057400"/>
           </a:xfrm>
           <a:prstGeom prst="roundRect">
             <a:avLst/>
           </a:prstGeom>
           <a:solidFill>
-            <a:srgbClr val="F0FDF4"/>
+            <a:srgbClr val="FFF7ED"/>
           </a:solidFill>
           <a:ln w="19050">
             <a:solidFill>
-              <a:srgbClr val="059669"/>
+              <a:srgbClr val="D97706"/>
             </a:solidFill>
           </a:ln>
         </p:spPr>
@@ -6235,7 +6236,7 @@
       </p:sp>
       <p:pic>
         <p:nvPicPr>
-          <p:cNvPr id="13" name="Picture 12" descr="icon_whatsapp.png"/>
+          <p:cNvPr id="15" name="Picture 14" descr="icon_offline.png"/>
           <p:cNvPicPr>
             <a:picLocks noChangeAspect="1"/>
           </p:cNvPicPr>
@@ -6249,7 +6250,7 @@
         </p:blipFill>
         <p:spPr>
           <a:xfrm>
-            <a:off x="8275320" y="1600200"/>
+            <a:off x="685800" y="3840480"/>
             <a:ext cx="1051560" cy="1051560"/>
           </a:xfrm>
           <a:prstGeom prst="rect">
@@ -6259,13 +6260,13 @@
       </p:pic>
       <p:sp>
         <p:nvSpPr>
-          <p:cNvPr id="14" name="TextBox 13"/>
+          <p:cNvPr id="16" name="TextBox 15"/>
           <p:cNvSpPr txBox="1"/>
           <p:nvPr/>
         </p:nvSpPr>
         <p:spPr>
           <a:xfrm>
-            <a:off x="9372600" y="1508760"/>
+            <a:off x="1783080" y="3749040"/>
             <a:ext cx="2240280" cy="1783080"/>
           </a:xfrm>
           <a:prstGeom prst="rect">
@@ -6285,13 +6286,13 @@
               </a:spcAft>
               <a:defRPr sz="1050" b="1">
                 <a:solidFill>
-                  <a:srgbClr val="059669"/>
+                  <a:srgbClr val="D97706"/>
                 </a:solidFill>
                 <a:latin typeface="Arial"/>
               </a:defRPr>
             </a:pPr>
             <a:r>
-              <a:t>Inclusive Multichannel Access</a:t>
+              <a:t>100% Offline Edge Resilient</a:t>
             </a:r>
           </a:p>
           <a:p>
@@ -6304,31 +6305,31 @@
               </a:defRPr>
             </a:pPr>
             <a:r>
-              <a:t>Zero barrier adoption: works via WhatsApp Bot, SMS fallback, and multilingual voice speech in 10+ Indic languages. No high digital literacy needed.</a:t>
-            </a:r>
-          </a:p>
-        </p:txBody>
-      </p:sp>
-      <p:sp>
-        <p:nvSpPr>
-          <p:cNvPr id="15" name="Rounded Rectangle 14"/>
+              <a:t>On-Device Snapdragon NPU vision and IndexedDB local storage ensure full functionality in deep rural farm fields with zero 4G/5G connectivity.</a:t>
+            </a:r>
+          </a:p>
+        </p:txBody>
+      </p:sp>
+      <p:sp>
+        <p:nvSpPr>
+          <p:cNvPr id="17" name="Rounded Rectangle 16"/>
           <p:cNvSpPr/>
           <p:nvPr/>
         </p:nvSpPr>
         <p:spPr>
           <a:xfrm>
-            <a:off x="548640" y="3611880"/>
+            <a:off x="4343400" y="3611880"/>
             <a:ext cx="3566160" cy="2057400"/>
           </a:xfrm>
           <a:prstGeom prst="roundRect">
             <a:avLst/>
           </a:prstGeom>
           <a:solidFill>
-            <a:srgbClr val="FFF7ED"/>
+            <a:srgbClr val="FAF5FF"/>
           </a:solidFill>
           <a:ln w="19050">
             <a:solidFill>
-              <a:srgbClr val="D97706"/>
+              <a:srgbClr val="7C3AED"/>
             </a:solidFill>
           </a:ln>
         </p:spPr>
@@ -6356,7 +6357,7 @@
       </p:sp>
       <p:pic>
         <p:nvPicPr>
-          <p:cNvPr id="16" name="Picture 15" descr="icon_offline.png"/>
+          <p:cNvPr id="18" name="Picture 17" descr="icon_farmer.png"/>
           <p:cNvPicPr>
             <a:picLocks noChangeAspect="1"/>
           </p:cNvPicPr>
@@ -6370,7 +6371,7 @@
         </p:blipFill>
         <p:spPr>
           <a:xfrm>
-            <a:off x="685800" y="3840480"/>
+            <a:off x="4480560" y="3840480"/>
             <a:ext cx="1051560" cy="1051560"/>
           </a:xfrm>
           <a:prstGeom prst="rect">
@@ -6380,13 +6381,13 @@
       </p:pic>
       <p:sp>
         <p:nvSpPr>
-          <p:cNvPr id="17" name="TextBox 16"/>
+          <p:cNvPr id="19" name="TextBox 18"/>
           <p:cNvSpPr txBox="1"/>
           <p:nvPr/>
         </p:nvSpPr>
         <p:spPr>
           <a:xfrm>
-            <a:off x="1783080" y="3749040"/>
+            <a:off x="5577840" y="3749040"/>
             <a:ext cx="2240280" cy="1783080"/>
           </a:xfrm>
           <a:prstGeom prst="rect">
@@ -6406,13 +6407,13 @@
               </a:spcAft>
               <a:defRPr sz="1050" b="1">
                 <a:solidFill>
-                  <a:srgbClr val="D97706"/>
+                  <a:srgbClr val="7C3AED"/>
                 </a:solidFill>
                 <a:latin typeface="Arial"/>
               </a:defRPr>
             </a:pPr>
             <a:r>
-              <a:t>100% Offline Edge Resilient</a:t>
+              <a:t>Marginal Farmer Empowerment</a:t>
             </a:r>
           </a:p>
           <a:p>
@@ -6425,31 +6426,31 @@
               </a:defRPr>
             </a:pPr>
             <a:r>
-              <a:t>On-Device Snapdragon NPU vision and IndexedDB local storage ensure full functionality in deep rural farm fields with zero 4G/5G connectivity.</a:t>
-            </a:r>
-          </a:p>
-        </p:txBody>
-      </p:sp>
-      <p:sp>
-        <p:nvSpPr>
-          <p:cNvPr id="18" name="Rounded Rectangle 17"/>
+              <a:t>Custom-tailored for 120M+ small &amp; marginal farmers, SC/ST rural entrepreneurs, and Women SHGs running localized farm-gate diagnostics.</a:t>
+            </a:r>
+          </a:p>
+        </p:txBody>
+      </p:sp>
+      <p:sp>
+        <p:nvSpPr>
+          <p:cNvPr id="20" name="Rounded Rectangle 19"/>
           <p:cNvSpPr/>
           <p:nvPr/>
         </p:nvSpPr>
         <p:spPr>
           <a:xfrm>
-            <a:off x="4343400" y="3611880"/>
+            <a:off x="8138160" y="3611880"/>
             <a:ext cx="3566160" cy="2057400"/>
           </a:xfrm>
           <a:prstGeom prst="roundRect">
             <a:avLst/>
           </a:prstGeom>
           <a:solidFill>
-            <a:srgbClr val="FAF5FF"/>
+            <a:srgbClr val="ECFEFF"/>
           </a:solidFill>
           <a:ln w="19050">
             <a:solidFill>
-              <a:srgbClr val="7C3AED"/>
+              <a:srgbClr val="0891B2"/>
             </a:solidFill>
           </a:ln>
         </p:spPr>
@@ -6477,7 +6478,7 @@
       </p:sp>
       <p:pic>
         <p:nvPicPr>
-          <p:cNvPr id="19" name="Picture 18" descr="icon_farmer.png"/>
+          <p:cNvPr id="21" name="Picture 20" descr="icon_explainable.png"/>
           <p:cNvPicPr>
             <a:picLocks noChangeAspect="1"/>
           </p:cNvPicPr>
@@ -6491,7 +6492,7 @@
         </p:blipFill>
         <p:spPr>
           <a:xfrm>
-            <a:off x="4480560" y="3840480"/>
+            <a:off x="8275320" y="3840480"/>
             <a:ext cx="1051560" cy="1051560"/>
           </a:xfrm>
           <a:prstGeom prst="rect">
@@ -6501,13 +6502,13 @@
       </p:pic>
       <p:sp>
         <p:nvSpPr>
-          <p:cNvPr id="20" name="TextBox 19"/>
+          <p:cNvPr id="22" name="TextBox 21"/>
           <p:cNvSpPr txBox="1"/>
           <p:nvPr/>
         </p:nvSpPr>
         <p:spPr>
           <a:xfrm>
-            <a:off x="5577840" y="3749040"/>
+            <a:off x="9372600" y="3749040"/>
             <a:ext cx="2240280" cy="1783080"/>
           </a:xfrm>
           <a:prstGeom prst="rect">
@@ -6527,13 +6528,13 @@
               </a:spcAft>
               <a:defRPr sz="1050" b="1">
                 <a:solidFill>
-                  <a:srgbClr val="7C3AED"/>
+                  <a:srgbClr val="0891B2"/>
                 </a:solidFill>
                 <a:latin typeface="Arial"/>
               </a:defRPr>
             </a:pPr>
             <a:r>
-              <a:t>Marginal Farmer Empowerment</a:t>
+              <a:t>Trust via Explainable AI</a:t>
             </a:r>
           </a:p>
           <a:p>
@@ -6546,127 +6547,6 @@
               </a:defRPr>
             </a:pPr>
             <a:r>
-              <a:t>Custom-tailored for 120M+ small &amp; marginal farmers, SC/ST rural entrepreneurs, and Women SHGs running localized farm-gate diagnostics.</a:t>
-            </a:r>
-          </a:p>
-        </p:txBody>
-      </p:sp>
-      <p:sp>
-        <p:nvSpPr>
-          <p:cNvPr id="21" name="Rounded Rectangle 20"/>
-          <p:cNvSpPr/>
-          <p:nvPr/>
-        </p:nvSpPr>
-        <p:spPr>
-          <a:xfrm>
-            <a:off x="8138160" y="3611880"/>
-            <a:ext cx="3566160" cy="2057400"/>
-          </a:xfrm>
-          <a:prstGeom prst="roundRect">
-            <a:avLst/>
-          </a:prstGeom>
-          <a:solidFill>
-            <a:srgbClr val="ECFEFF"/>
-          </a:solidFill>
-          <a:ln w="19050">
-            <a:solidFill>
-              <a:srgbClr val="0891B2"/>
-            </a:solidFill>
-          </a:ln>
-        </p:spPr>
-        <p:style>
-          <a:lnRef idx="1">
-            <a:schemeClr val="accent1"/>
-          </a:lnRef>
-          <a:fillRef idx="3">
-            <a:schemeClr val="accent1"/>
-          </a:fillRef>
-          <a:effectRef idx="2">
-            <a:schemeClr val="accent1"/>
-          </a:effectRef>
-          <a:fontRef idx="minor">
-            <a:schemeClr val="lt1"/>
-          </a:fontRef>
-        </p:style>
-        <p:txBody>
-          <a:bodyPr rtlCol="0" anchor="ctr"/>
-          <a:lstStyle/>
-          <a:p>
-            <a:pPr algn="ctr"/>
-          </a:p>
-        </p:txBody>
-      </p:sp>
-      <p:pic>
-        <p:nvPicPr>
-          <p:cNvPr id="22" name="Picture 21" descr="icon_explainable.png"/>
-          <p:cNvPicPr>
-            <a:picLocks noChangeAspect="1"/>
-          </p:cNvPicPr>
-          <p:nvPr/>
-        </p:nvPicPr>
-        <p:blipFill>
-          <a:blip r:embed="rId9"/>
-          <a:stretch>
-            <a:fillRect/>
-          </a:stretch>
-        </p:blipFill>
-        <p:spPr>
-          <a:xfrm>
-            <a:off x="8275320" y="3840480"/>
-            <a:ext cx="1051560" cy="1051560"/>
-          </a:xfrm>
-          <a:prstGeom prst="rect">
-            <a:avLst/>
-          </a:prstGeom>
-        </p:spPr>
-      </p:pic>
-      <p:sp>
-        <p:nvSpPr>
-          <p:cNvPr id="23" name="TextBox 22"/>
-          <p:cNvSpPr txBox="1"/>
-          <p:nvPr/>
-        </p:nvSpPr>
-        <p:spPr>
-          <a:xfrm>
-            <a:off x="9372600" y="3749040"/>
-            <a:ext cx="2240280" cy="1783080"/>
-          </a:xfrm>
-          <a:prstGeom prst="rect">
-            <a:avLst/>
-          </a:prstGeom>
-          <a:noFill/>
-        </p:spPr>
-        <p:txBody>
-          <a:bodyPr wrap="square">
-            <a:spAutoFit/>
-          </a:bodyPr>
-          <a:lstStyle/>
-          <a:p>
-            <a:pPr>
-              <a:spcAft>
-                <a:spcPts val="400"/>
-              </a:spcAft>
-              <a:defRPr sz="1050" b="1">
-                <a:solidFill>
-                  <a:srgbClr val="0891B2"/>
-                </a:solidFill>
-                <a:latin typeface="Arial"/>
-              </a:defRPr>
-            </a:pPr>
-            <a:r>
-              <a:t>Trust via Explainable AI</a:t>
-            </a:r>
-          </a:p>
-          <a:p>
-            <a:pPr>
-              <a:defRPr sz="850">
-                <a:solidFill>
-                  <a:srgbClr val="334155"/>
-                </a:solidFill>
-                <a:latin typeface="Arial"/>
-              </a:defRPr>
-            </a:pPr>
-            <a:r>
               <a:t>Every recommendation provides transparent 'WHY' causal reasoning, organic biological controls (Neem/Trichoderma), and government-approved chemical dosages.</a:t>
             </a:r>
           </a:p>
@@ -6674,7 +6554,7 @@
       </p:sp>
       <p:sp>
         <p:nvSpPr>
-          <p:cNvPr id="24" name="Rounded Rectangle 23"/>
+          <p:cNvPr id="23" name="Rounded Rectangle 22"/>
           <p:cNvSpPr/>
           <p:nvPr/>
         </p:nvSpPr>
@@ -6727,7 +6607,7 @@
       </p:sp>
       <p:sp>
         <p:nvSpPr>
-          <p:cNvPr id="25" name="Rectangle 24"/>
+          <p:cNvPr id="24" name="Rectangle 23"/>
           <p:cNvSpPr/>
           <p:nvPr/>
         </p:nvSpPr>
@@ -6773,7 +6653,7 @@
               </a:defRPr>
             </a:pPr>
             <a:r>
-              <a:t>@Qualcomm Snapdragon® AI Lab Build &amp; Present Challenge 2026  |  Project: Kisan Sahayak AI  |  Developer: MOHD UBES                 Page 5</a:t>
+              <a:t>Project: Kisan Sahayak AI   |   Developer: MOHD UBES   |   Snapdragon® AI Lab Build &amp; Present Challenge 2026                 Page 5</a:t>
             </a:r>
           </a:p>
         </p:txBody>
@@ -6828,8 +6708,8 @@
         </p:nvSpPr>
         <p:spPr>
           <a:xfrm>
-            <a:off x="1645920" y="274320"/>
-            <a:ext cx="8046720" cy="868680"/>
+            <a:off x="1463040" y="274320"/>
+            <a:ext cx="10241280" cy="868680"/>
           </a:xfrm>
           <a:prstGeom prst="rect">
             <a:avLst/>
@@ -6843,7 +6723,7 @@
           <a:lstStyle/>
           <a:p>
             <a:pPr algn="ctr">
-              <a:defRPr sz="2100" b="1">
+              <a:defRPr sz="2200" b="1">
                 <a:solidFill>
                   <a:srgbClr val="0F172A"/>
                 </a:solidFill>
@@ -6860,33 +6740,9 @@
           </a:p>
         </p:txBody>
       </p:sp>
-      <p:pic>
-        <p:nvPicPr>
-          <p:cNvPr id="4" name="Picture 3" descr="challenge_logo.png"/>
-          <p:cNvPicPr>
-            <a:picLocks noChangeAspect="1"/>
-          </p:cNvPicPr>
-          <p:nvPr/>
-        </p:nvPicPr>
-        <p:blipFill>
-          <a:blip r:embed="rId3"/>
-          <a:stretch>
-            <a:fillRect/>
-          </a:stretch>
-        </p:blipFill>
-        <p:spPr>
-          <a:xfrm>
-            <a:off x="10058400" y="228600"/>
-            <a:ext cx="1645920" cy="914400"/>
-          </a:xfrm>
-          <a:prstGeom prst="rect">
-            <a:avLst/>
-          </a:prstGeom>
-        </p:spPr>
-      </p:pic>
-      <p:sp>
-        <p:nvSpPr>
-          <p:cNvPr id="5" name="Rectangle 4"/>
+      <p:sp>
+        <p:nvSpPr>
+          <p:cNvPr id="4" name="Rectangle 3"/>
           <p:cNvSpPr/>
           <p:nvPr/>
         </p:nvSpPr>
@@ -6931,7 +6787,7 @@
       </p:sp>
       <p:sp>
         <p:nvSpPr>
-          <p:cNvPr id="6" name="Rounded Rectangle 5"/>
+          <p:cNvPr id="5" name="Rounded Rectangle 4"/>
           <p:cNvSpPr/>
           <p:nvPr/>
         </p:nvSpPr>
@@ -7041,7 +6897,7 @@
               </a:defRPr>
             </a:pPr>
             <a:r>
-              <a:t>• Jan Samarth Portal &amp; UMANG App: Unified government credit linkage and agricultural subsidy schemes.</a:t>
+              <a:t>• Jan Samarth Portal &amp; UMANG App: Unified government subsidy frameworks and credit linkage norms.</a:t>
             </a:r>
           </a:p>
           <a:p>
@@ -7078,7 +6934,7 @@
       </p:sp>
       <p:graphicFrame>
         <p:nvGraphicFramePr>
-          <p:cNvPr id="7" name="Table 6"/>
+          <p:cNvPr id="6" name="Table 5"/>
           <p:cNvGraphicFramePr>
             <a:graphicFrameLocks noGrp="1"/>
           </p:cNvGraphicFramePr>
@@ -7858,7 +7714,7 @@
       </p:graphicFrame>
       <p:sp>
         <p:nvSpPr>
-          <p:cNvPr id="8" name="Rectangle 7"/>
+          <p:cNvPr id="7" name="Rectangle 6"/>
           <p:cNvSpPr/>
           <p:nvPr/>
         </p:nvSpPr>
@@ -7904,7 +7760,7 @@
               </a:defRPr>
             </a:pPr>
             <a:r>
-              <a:t>@Qualcomm Snapdragon® AI Lab Build &amp; Present Challenge 2026  |  Project: Kisan Sahayak AI  |  Developer: MOHD UBES                 Page 6</a:t>
+              <a:t>Project: Kisan Sahayak AI   |   Developer: MOHD UBES   |   Snapdragon® AI Lab Build &amp; Present Challenge 2026                 Page 6</a:t>
             </a:r>
           </a:p>
         </p:txBody>

</xml_diff>